<commit_message>
analytics_dashboards - added page with typical data architecture
</commit_message>
<xml_diff>
--- a/analytics_dashboards.pptx
+++ b/analytics_dashboards.pptx
@@ -5,16 +5,17 @@
     <p:sldMasterId id="2147483659" r:id="rId1"/>
   </p:sldMasterIdLst>
   <p:notesMasterIdLst>
-    <p:notesMasterId r:id="rId9"/>
+    <p:notesMasterId r:id="rId10"/>
   </p:notesMasterIdLst>
   <p:sldIdLst>
     <p:sldId id="256" r:id="rId2"/>
     <p:sldId id="257" r:id="rId3"/>
     <p:sldId id="258" r:id="rId4"/>
     <p:sldId id="262" r:id="rId5"/>
-    <p:sldId id="259" r:id="rId6"/>
-    <p:sldId id="260" r:id="rId7"/>
+    <p:sldId id="263" r:id="rId6"/>
+    <p:sldId id="259" r:id="rId7"/>
     <p:sldId id="261" r:id="rId8"/>
+    <p:sldId id="260" r:id="rId9"/>
   </p:sldIdLst>
   <p:sldSz cx="12192000" cy="6858000"/>
   <p:notesSz cx="6858000" cy="9144000"/>
@@ -2034,7 +2035,7 @@
             </a:pPr>
             <a:fld id="{00000000-1234-1234-1234-123412341234}" type="slidenum">
               <a:rPr lang="en-US"/>
-              <a:t>5</a:t>
+              <a:t>6</a:t>
             </a:fld>
             <a:endParaRPr/>
           </a:p>
@@ -2184,7 +2185,7 @@
             </a:pPr>
             <a:fld id="{00000000-1234-1234-1234-123412341234}" type="slidenum">
               <a:rPr lang="en-US"/>
-              <a:t>6</a:t>
+              <a:t>8</a:t>
             </a:fld>
             <a:endParaRPr/>
           </a:p>
@@ -19925,6 +19926,773 @@
   <p:cSld>
     <p:spTree>
       <p:nvGrpSpPr>
+        <p:cNvPr id="1" name=""/>
+        <p:cNvGrpSpPr/>
+        <p:nvPr/>
+      </p:nvGrpSpPr>
+      <p:grpSpPr>
+        <a:xfrm>
+          <a:off x="0" y="0"/>
+          <a:ext cx="0" cy="0"/>
+          <a:chOff x="0" y="0"/>
+          <a:chExt cx="0" cy="0"/>
+        </a:xfrm>
+      </p:grpSpPr>
+      <p:sp>
+        <p:nvSpPr>
+          <p:cNvPr id="2" name="TextBox 1">
+            <a:extLst>
+              <a:ext uri="{FF2B5EF4-FFF2-40B4-BE49-F238E27FC236}">
+                <a16:creationId xmlns:a16="http://schemas.microsoft.com/office/drawing/2014/main" id="{25130DB6-EAE0-B841-A247-A5E02499036A}"/>
+              </a:ext>
+            </a:extLst>
+          </p:cNvPr>
+          <p:cNvSpPr txBox="1"/>
+          <p:nvPr/>
+        </p:nvSpPr>
+        <p:spPr>
+          <a:xfrm>
+            <a:off x="0" y="93785"/>
+            <a:ext cx="5556738" cy="461665"/>
+          </a:xfrm>
+          <a:prstGeom prst="rect">
+            <a:avLst/>
+          </a:prstGeom>
+          <a:noFill/>
+        </p:spPr>
+        <p:txBody>
+          <a:bodyPr wrap="square" rtlCol="0">
+            <a:spAutoFit/>
+          </a:bodyPr>
+          <a:lstStyle/>
+          <a:p>
+            <a:r>
+              <a:rPr lang="en-US" sz="2400" b="1" dirty="0">
+                <a:latin typeface="Calibri"/>
+                <a:ea typeface="Calibri"/>
+                <a:cs typeface="Calibri"/>
+                <a:sym typeface="Calibri"/>
+              </a:rPr>
+              <a:t>Typical Data Organization for Analytics</a:t>
+            </a:r>
+          </a:p>
+        </p:txBody>
+      </p:sp>
+      <p:sp>
+        <p:nvSpPr>
+          <p:cNvPr id="3" name="Can 2">
+            <a:extLst>
+              <a:ext uri="{FF2B5EF4-FFF2-40B4-BE49-F238E27FC236}">
+                <a16:creationId xmlns:a16="http://schemas.microsoft.com/office/drawing/2014/main" id="{854B268A-643E-9B4F-B623-63EFBF3615A0}"/>
+              </a:ext>
+            </a:extLst>
+          </p:cNvPr>
+          <p:cNvSpPr/>
+          <p:nvPr/>
+        </p:nvSpPr>
+        <p:spPr>
+          <a:xfrm>
+            <a:off x="779216" y="978078"/>
+            <a:ext cx="984738" cy="1254369"/>
+          </a:xfrm>
+          <a:prstGeom prst="can">
+            <a:avLst/>
+          </a:prstGeom>
+        </p:spPr>
+        <p:style>
+          <a:lnRef idx="2">
+            <a:schemeClr val="accent1">
+              <a:shade val="50000"/>
+            </a:schemeClr>
+          </a:lnRef>
+          <a:fillRef idx="1">
+            <a:schemeClr val="accent1"/>
+          </a:fillRef>
+          <a:effectRef idx="0">
+            <a:schemeClr val="accent1"/>
+          </a:effectRef>
+          <a:fontRef idx="minor">
+            <a:schemeClr val="lt1"/>
+          </a:fontRef>
+        </p:style>
+        <p:txBody>
+          <a:bodyPr rtlCol="0" anchor="ctr"/>
+          <a:lstStyle/>
+          <a:p>
+            <a:pPr algn="ctr"/>
+            <a:r>
+              <a:rPr lang="en-US" dirty="0"/>
+              <a:t>OLTP</a:t>
+            </a:r>
+          </a:p>
+          <a:p>
+            <a:pPr algn="ctr"/>
+            <a:r>
+              <a:rPr lang="en-US" dirty="0"/>
+              <a:t>DB</a:t>
+            </a:r>
+          </a:p>
+        </p:txBody>
+      </p:sp>
+      <p:pic>
+        <p:nvPicPr>
+          <p:cNvPr id="1026" name="Picture 2" descr="Multiple Files Icon - 6244 - Dryicons">
+            <a:extLst>
+              <a:ext uri="{FF2B5EF4-FFF2-40B4-BE49-F238E27FC236}">
+                <a16:creationId xmlns:a16="http://schemas.microsoft.com/office/drawing/2014/main" id="{318D204D-22B8-154C-8595-E8A970098AE0}"/>
+              </a:ext>
+            </a:extLst>
+          </p:cNvPr>
+          <p:cNvPicPr>
+            <a:picLocks noChangeAspect="1" noChangeArrowheads="1"/>
+          </p:cNvPicPr>
+          <p:nvPr/>
+        </p:nvPicPr>
+        <p:blipFill>
+          <a:blip r:embed="rId2" cstate="email">
+            <a:extLst>
+              <a:ext uri="{28A0092B-C50C-407E-A947-70E740481C1C}">
+                <a14:useLocalDpi xmlns:a14="http://schemas.microsoft.com/office/drawing/2010/main"/>
+              </a:ext>
+            </a:extLst>
+          </a:blip>
+          <a:srcRect/>
+          <a:stretch>
+            <a:fillRect/>
+          </a:stretch>
+        </p:blipFill>
+        <p:spPr bwMode="auto">
+          <a:xfrm>
+            <a:off x="128586" y="2492977"/>
+            <a:ext cx="1184031" cy="1184031"/>
+          </a:xfrm>
+          <a:prstGeom prst="rect">
+            <a:avLst/>
+          </a:prstGeom>
+          <a:noFill/>
+          <a:extLst>
+            <a:ext uri="{909E8E84-426E-40DD-AFC4-6F175D3DCCD1}">
+              <a14:hiddenFill xmlns:a14="http://schemas.microsoft.com/office/drawing/2010/main">
+                <a:solidFill>
+                  <a:srgbClr val="FFFFFF"/>
+                </a:solidFill>
+              </a14:hiddenFill>
+            </a:ext>
+          </a:extLst>
+        </p:spPr>
+      </p:pic>
+      <p:sp>
+        <p:nvSpPr>
+          <p:cNvPr id="4" name="TextBox 3">
+            <a:extLst>
+              <a:ext uri="{FF2B5EF4-FFF2-40B4-BE49-F238E27FC236}">
+                <a16:creationId xmlns:a16="http://schemas.microsoft.com/office/drawing/2014/main" id="{65BB060B-5423-9043-8B16-33F8CFBAE9E8}"/>
+              </a:ext>
+            </a:extLst>
+          </p:cNvPr>
+          <p:cNvSpPr txBox="1"/>
+          <p:nvPr/>
+        </p:nvSpPr>
+        <p:spPr>
+          <a:xfrm>
+            <a:off x="280986" y="3763054"/>
+            <a:ext cx="679938" cy="307777"/>
+          </a:xfrm>
+          <a:prstGeom prst="rect">
+            <a:avLst/>
+          </a:prstGeom>
+          <a:noFill/>
+        </p:spPr>
+        <p:txBody>
+          <a:bodyPr wrap="square" rtlCol="0">
+            <a:spAutoFit/>
+          </a:bodyPr>
+          <a:lstStyle/>
+          <a:p>
+            <a:r>
+              <a:rPr lang="en-US" dirty="0"/>
+              <a:t>Files</a:t>
+            </a:r>
+          </a:p>
+        </p:txBody>
+      </p:sp>
+      <p:pic>
+        <p:nvPicPr>
+          <p:cNvPr id="1028" name="Picture 4" descr="Rest API Icon - Free Download, PNG and Vector">
+            <a:extLst>
+              <a:ext uri="{FF2B5EF4-FFF2-40B4-BE49-F238E27FC236}">
+                <a16:creationId xmlns:a16="http://schemas.microsoft.com/office/drawing/2014/main" id="{0811F92F-5393-A449-AC67-E99DFE48DF8A}"/>
+              </a:ext>
+            </a:extLst>
+          </p:cNvPr>
+          <p:cNvPicPr>
+            <a:picLocks noChangeAspect="1" noChangeArrowheads="1"/>
+          </p:cNvPicPr>
+          <p:nvPr/>
+        </p:nvPicPr>
+        <p:blipFill>
+          <a:blip r:embed="rId3" cstate="email">
+            <a:extLst>
+              <a:ext uri="{28A0092B-C50C-407E-A947-70E740481C1C}">
+                <a14:useLocalDpi xmlns:a14="http://schemas.microsoft.com/office/drawing/2010/main"/>
+              </a:ext>
+            </a:extLst>
+          </a:blip>
+          <a:srcRect/>
+          <a:stretch>
+            <a:fillRect/>
+          </a:stretch>
+        </p:blipFill>
+        <p:spPr bwMode="auto">
+          <a:xfrm>
+            <a:off x="820248" y="4156877"/>
+            <a:ext cx="984738" cy="984738"/>
+          </a:xfrm>
+          <a:prstGeom prst="rect">
+            <a:avLst/>
+          </a:prstGeom>
+          <a:noFill/>
+          <a:extLst>
+            <a:ext uri="{909E8E84-426E-40DD-AFC4-6F175D3DCCD1}">
+              <a14:hiddenFill xmlns:a14="http://schemas.microsoft.com/office/drawing/2010/main">
+                <a:solidFill>
+                  <a:srgbClr val="FFFFFF"/>
+                </a:solidFill>
+              </a14:hiddenFill>
+            </a:ext>
+          </a:extLst>
+        </p:spPr>
+      </p:pic>
+      <p:pic>
+        <p:nvPicPr>
+          <p:cNvPr id="1030" name="Picture 6" descr="Analytics, olap, big data icon - Download on Iconfinder">
+            <a:extLst>
+              <a:ext uri="{FF2B5EF4-FFF2-40B4-BE49-F238E27FC236}">
+                <a16:creationId xmlns:a16="http://schemas.microsoft.com/office/drawing/2014/main" id="{5BB445C1-D1D3-684A-BB8A-85774096627A}"/>
+              </a:ext>
+            </a:extLst>
+          </p:cNvPr>
+          <p:cNvPicPr>
+            <a:picLocks noChangeAspect="1" noChangeArrowheads="1"/>
+          </p:cNvPicPr>
+          <p:nvPr/>
+        </p:nvPicPr>
+        <p:blipFill rotWithShape="1">
+          <a:blip r:embed="rId4" cstate="email">
+            <a:extLst>
+              <a:ext uri="{28A0092B-C50C-407E-A947-70E740481C1C}">
+                <a14:useLocalDpi xmlns:a14="http://schemas.microsoft.com/office/drawing/2010/main"/>
+              </a:ext>
+            </a:extLst>
+          </a:blip>
+          <a:srcRect l="12325" t="12774" r="12388" b="11796"/>
+          <a:stretch/>
+        </p:blipFill>
+        <p:spPr bwMode="auto">
+          <a:xfrm>
+            <a:off x="4048551" y="2040538"/>
+            <a:ext cx="2112335" cy="2116339"/>
+          </a:xfrm>
+          <a:prstGeom prst="rect">
+            <a:avLst/>
+          </a:prstGeom>
+          <a:noFill/>
+          <a:extLst>
+            <a:ext uri="{909E8E84-426E-40DD-AFC4-6F175D3DCCD1}">
+              <a14:hiddenFill xmlns:a14="http://schemas.microsoft.com/office/drawing/2010/main">
+                <a:solidFill>
+                  <a:srgbClr val="FFFFFF"/>
+                </a:solidFill>
+              </a14:hiddenFill>
+            </a:ext>
+          </a:extLst>
+        </p:spPr>
+      </p:pic>
+      <p:sp>
+        <p:nvSpPr>
+          <p:cNvPr id="5" name="Right Arrow 4">
+            <a:extLst>
+              <a:ext uri="{FF2B5EF4-FFF2-40B4-BE49-F238E27FC236}">
+                <a16:creationId xmlns:a16="http://schemas.microsoft.com/office/drawing/2014/main" id="{C9126FF6-C14E-7B4F-BF11-8F22787B6C46}"/>
+              </a:ext>
+            </a:extLst>
+          </p:cNvPr>
+          <p:cNvSpPr/>
+          <p:nvPr/>
+        </p:nvSpPr>
+        <p:spPr>
+          <a:xfrm>
+            <a:off x="2166352" y="2478690"/>
+            <a:ext cx="1406769" cy="1312252"/>
+          </a:xfrm>
+          <a:prstGeom prst="rightArrow">
+            <a:avLst/>
+          </a:prstGeom>
+          <a:solidFill>
+            <a:schemeClr val="accent1">
+              <a:lumMod val="20000"/>
+              <a:lumOff val="80000"/>
+            </a:schemeClr>
+          </a:solidFill>
+          <a:ln>
+            <a:solidFill>
+              <a:schemeClr val="accent1"/>
+            </a:solidFill>
+          </a:ln>
+        </p:spPr>
+        <p:style>
+          <a:lnRef idx="2">
+            <a:schemeClr val="accent1">
+              <a:shade val="50000"/>
+            </a:schemeClr>
+          </a:lnRef>
+          <a:fillRef idx="1">
+            <a:schemeClr val="accent1"/>
+          </a:fillRef>
+          <a:effectRef idx="0">
+            <a:schemeClr val="accent1"/>
+          </a:effectRef>
+          <a:fontRef idx="minor">
+            <a:schemeClr val="lt1"/>
+          </a:fontRef>
+        </p:style>
+        <p:txBody>
+          <a:bodyPr rtlCol="0" anchor="ctr"/>
+          <a:lstStyle/>
+          <a:p>
+            <a:pPr algn="ctr"/>
+            <a:endParaRPr lang="en-US"/>
+          </a:p>
+        </p:txBody>
+      </p:sp>
+      <p:sp>
+        <p:nvSpPr>
+          <p:cNvPr id="9" name="Right Arrow 8">
+            <a:extLst>
+              <a:ext uri="{FF2B5EF4-FFF2-40B4-BE49-F238E27FC236}">
+                <a16:creationId xmlns:a16="http://schemas.microsoft.com/office/drawing/2014/main" id="{15835FB6-081A-CB44-A9F4-C47DBE54889D}"/>
+              </a:ext>
+            </a:extLst>
+          </p:cNvPr>
+          <p:cNvSpPr/>
+          <p:nvPr/>
+        </p:nvSpPr>
+        <p:spPr>
+          <a:xfrm>
+            <a:off x="6903065" y="3338503"/>
+            <a:ext cx="1406769" cy="452439"/>
+          </a:xfrm>
+          <a:prstGeom prst="rightArrow">
+            <a:avLst/>
+          </a:prstGeom>
+          <a:solidFill>
+            <a:schemeClr val="accent1">
+              <a:lumMod val="20000"/>
+              <a:lumOff val="80000"/>
+            </a:schemeClr>
+          </a:solidFill>
+          <a:ln>
+            <a:solidFill>
+              <a:schemeClr val="accent1"/>
+            </a:solidFill>
+          </a:ln>
+        </p:spPr>
+        <p:style>
+          <a:lnRef idx="2">
+            <a:schemeClr val="accent1">
+              <a:shade val="50000"/>
+            </a:schemeClr>
+          </a:lnRef>
+          <a:fillRef idx="1">
+            <a:schemeClr val="accent1"/>
+          </a:fillRef>
+          <a:effectRef idx="0">
+            <a:schemeClr val="accent1"/>
+          </a:effectRef>
+          <a:fontRef idx="minor">
+            <a:schemeClr val="lt1"/>
+          </a:fontRef>
+        </p:style>
+        <p:txBody>
+          <a:bodyPr rtlCol="0" anchor="ctr"/>
+          <a:lstStyle/>
+          <a:p>
+            <a:pPr algn="ctr"/>
+            <a:endParaRPr lang="en-US"/>
+          </a:p>
+        </p:txBody>
+      </p:sp>
+      <p:sp>
+        <p:nvSpPr>
+          <p:cNvPr id="10" name="Right Arrow 9">
+            <a:extLst>
+              <a:ext uri="{FF2B5EF4-FFF2-40B4-BE49-F238E27FC236}">
+                <a16:creationId xmlns:a16="http://schemas.microsoft.com/office/drawing/2014/main" id="{24322037-4F54-9E4D-A0FB-F0F681C10D99}"/>
+              </a:ext>
+            </a:extLst>
+          </p:cNvPr>
+          <p:cNvSpPr/>
+          <p:nvPr/>
+        </p:nvSpPr>
+        <p:spPr>
+          <a:xfrm rot="10800000">
+            <a:off x="6677510" y="2552691"/>
+            <a:ext cx="1406769" cy="452439"/>
+          </a:xfrm>
+          <a:prstGeom prst="rightArrow">
+            <a:avLst/>
+          </a:prstGeom>
+          <a:solidFill>
+            <a:schemeClr val="accent1">
+              <a:lumMod val="20000"/>
+              <a:lumOff val="80000"/>
+            </a:schemeClr>
+          </a:solidFill>
+          <a:ln>
+            <a:solidFill>
+              <a:schemeClr val="accent1"/>
+            </a:solidFill>
+          </a:ln>
+        </p:spPr>
+        <p:style>
+          <a:lnRef idx="2">
+            <a:schemeClr val="accent1">
+              <a:shade val="50000"/>
+            </a:schemeClr>
+          </a:lnRef>
+          <a:fillRef idx="1">
+            <a:schemeClr val="accent1"/>
+          </a:fillRef>
+          <a:effectRef idx="0">
+            <a:schemeClr val="accent1"/>
+          </a:effectRef>
+          <a:fontRef idx="minor">
+            <a:schemeClr val="lt1"/>
+          </a:fontRef>
+        </p:style>
+        <p:txBody>
+          <a:bodyPr rtlCol="0" anchor="ctr"/>
+          <a:lstStyle/>
+          <a:p>
+            <a:pPr algn="ctr"/>
+            <a:endParaRPr lang="en-US"/>
+          </a:p>
+        </p:txBody>
+      </p:sp>
+      <p:sp>
+        <p:nvSpPr>
+          <p:cNvPr id="6" name="TextBox 5">
+            <a:extLst>
+              <a:ext uri="{FF2B5EF4-FFF2-40B4-BE49-F238E27FC236}">
+                <a16:creationId xmlns:a16="http://schemas.microsoft.com/office/drawing/2014/main" id="{853F1EDF-504A-2F45-8374-23559C7C26DD}"/>
+              </a:ext>
+            </a:extLst>
+          </p:cNvPr>
+          <p:cNvSpPr txBox="1"/>
+          <p:nvPr/>
+        </p:nvSpPr>
+        <p:spPr>
+          <a:xfrm>
+            <a:off x="7015145" y="2232447"/>
+            <a:ext cx="1069134" cy="369332"/>
+          </a:xfrm>
+          <a:prstGeom prst="rect">
+            <a:avLst/>
+          </a:prstGeom>
+          <a:noFill/>
+        </p:spPr>
+        <p:txBody>
+          <a:bodyPr wrap="square" rtlCol="0">
+            <a:spAutoFit/>
+          </a:bodyPr>
+          <a:lstStyle/>
+          <a:p>
+            <a:r>
+              <a:rPr lang="en-US" sz="1800" dirty="0"/>
+              <a:t>Queries</a:t>
+            </a:r>
+          </a:p>
+        </p:txBody>
+      </p:sp>
+      <p:sp>
+        <p:nvSpPr>
+          <p:cNvPr id="12" name="TextBox 11">
+            <a:extLst>
+              <a:ext uri="{FF2B5EF4-FFF2-40B4-BE49-F238E27FC236}">
+                <a16:creationId xmlns:a16="http://schemas.microsoft.com/office/drawing/2014/main" id="{3482BCAC-B9B4-F045-8EF9-1BC8FFB72315}"/>
+              </a:ext>
+            </a:extLst>
+          </p:cNvPr>
+          <p:cNvSpPr txBox="1"/>
+          <p:nvPr/>
+        </p:nvSpPr>
+        <p:spPr>
+          <a:xfrm>
+            <a:off x="6929211" y="3736694"/>
+            <a:ext cx="1069134" cy="369332"/>
+          </a:xfrm>
+          <a:prstGeom prst="rect">
+            <a:avLst/>
+          </a:prstGeom>
+          <a:noFill/>
+        </p:spPr>
+        <p:txBody>
+          <a:bodyPr wrap="square" rtlCol="0">
+            <a:spAutoFit/>
+          </a:bodyPr>
+          <a:lstStyle/>
+          <a:p>
+            <a:r>
+              <a:rPr lang="en-US" sz="1800" dirty="0"/>
+              <a:t>Results</a:t>
+            </a:r>
+          </a:p>
+        </p:txBody>
+      </p:sp>
+      <p:pic>
+        <p:nvPicPr>
+          <p:cNvPr id="1032" name="Picture 8" descr="Interactive Dashboards - Benefits">
+            <a:extLst>
+              <a:ext uri="{FF2B5EF4-FFF2-40B4-BE49-F238E27FC236}">
+                <a16:creationId xmlns:a16="http://schemas.microsoft.com/office/drawing/2014/main" id="{35987B55-3385-A049-8191-961CDB844671}"/>
+              </a:ext>
+            </a:extLst>
+          </p:cNvPr>
+          <p:cNvPicPr>
+            <a:picLocks noChangeAspect="1" noChangeArrowheads="1"/>
+          </p:cNvPicPr>
+          <p:nvPr/>
+        </p:nvPicPr>
+        <p:blipFill>
+          <a:blip r:embed="rId5" cstate="email">
+            <a:extLst>
+              <a:ext uri="{28A0092B-C50C-407E-A947-70E740481C1C}">
+                <a14:useLocalDpi xmlns:a14="http://schemas.microsoft.com/office/drawing/2010/main"/>
+              </a:ext>
+            </a:extLst>
+          </a:blip>
+          <a:srcRect/>
+          <a:stretch>
+            <a:fillRect/>
+          </a:stretch>
+        </p:blipFill>
+        <p:spPr bwMode="auto">
+          <a:xfrm>
+            <a:off x="8852604" y="2232447"/>
+            <a:ext cx="3253943" cy="1968772"/>
+          </a:xfrm>
+          <a:prstGeom prst="rect">
+            <a:avLst/>
+          </a:prstGeom>
+          <a:noFill/>
+          <a:extLst>
+            <a:ext uri="{909E8E84-426E-40DD-AFC4-6F175D3DCCD1}">
+              <a14:hiddenFill xmlns:a14="http://schemas.microsoft.com/office/drawing/2010/main">
+                <a:solidFill>
+                  <a:srgbClr val="FFFFFF"/>
+                </a:solidFill>
+              </a14:hiddenFill>
+            </a:ext>
+          </a:extLst>
+        </p:spPr>
+      </p:pic>
+      <p:sp>
+        <p:nvSpPr>
+          <p:cNvPr id="7" name="TextBox 6">
+            <a:extLst>
+              <a:ext uri="{FF2B5EF4-FFF2-40B4-BE49-F238E27FC236}">
+                <a16:creationId xmlns:a16="http://schemas.microsoft.com/office/drawing/2014/main" id="{455B5DC0-E23C-EC49-96AC-723901C51D49}"/>
+              </a:ext>
+            </a:extLst>
+          </p:cNvPr>
+          <p:cNvSpPr txBox="1"/>
+          <p:nvPr/>
+        </p:nvSpPr>
+        <p:spPr>
+          <a:xfrm>
+            <a:off x="3573121" y="4201922"/>
+            <a:ext cx="3104389" cy="1200329"/>
+          </a:xfrm>
+          <a:prstGeom prst="rect">
+            <a:avLst/>
+          </a:prstGeom>
+          <a:noFill/>
+        </p:spPr>
+        <p:txBody>
+          <a:bodyPr wrap="square" rtlCol="0">
+            <a:spAutoFit/>
+          </a:bodyPr>
+          <a:lstStyle/>
+          <a:p>
+            <a:pPr algn="ctr"/>
+            <a:r>
+              <a:rPr lang="en-US" sz="1800" b="1" dirty="0">
+                <a:solidFill>
+                  <a:srgbClr val="0070C0"/>
+                </a:solidFill>
+              </a:rPr>
+              <a:t>OLAP database </a:t>
+            </a:r>
+            <a:br>
+              <a:rPr lang="en-US" sz="1800" b="1" dirty="0">
+                <a:solidFill>
+                  <a:srgbClr val="0070C0"/>
+                </a:solidFill>
+              </a:rPr>
+            </a:br>
+            <a:r>
+              <a:rPr lang="en-US" sz="1800" b="1" dirty="0">
+                <a:solidFill>
+                  <a:srgbClr val="0070C0"/>
+                </a:solidFill>
+              </a:rPr>
+              <a:t>with columnar storage </a:t>
+            </a:r>
+            <a:br>
+              <a:rPr lang="en-US" sz="1800" dirty="0"/>
+            </a:br>
+            <a:r>
+              <a:rPr lang="en-US" sz="1800" dirty="0"/>
+              <a:t>for fast and flexible querying</a:t>
+            </a:r>
+            <a:br>
+              <a:rPr lang="en-US" sz="1800" dirty="0"/>
+            </a:br>
+            <a:r>
+              <a:rPr lang="en-US" sz="1800" dirty="0"/>
+              <a:t>(a.k.a. Analytical Store).</a:t>
+            </a:r>
+          </a:p>
+        </p:txBody>
+      </p:sp>
+      <p:sp>
+        <p:nvSpPr>
+          <p:cNvPr id="8" name="TextBox 7">
+            <a:extLst>
+              <a:ext uri="{FF2B5EF4-FFF2-40B4-BE49-F238E27FC236}">
+                <a16:creationId xmlns:a16="http://schemas.microsoft.com/office/drawing/2014/main" id="{D0EF4D67-6F3D-4740-AB35-D5180A5AB412}"/>
+              </a:ext>
+            </a:extLst>
+          </p:cNvPr>
+          <p:cNvSpPr txBox="1"/>
+          <p:nvPr/>
+        </p:nvSpPr>
+        <p:spPr>
+          <a:xfrm>
+            <a:off x="6889421" y="5967919"/>
+            <a:ext cx="5217126" cy="584775"/>
+          </a:xfrm>
+          <a:prstGeom prst="rect">
+            <a:avLst/>
+          </a:prstGeom>
+          <a:noFill/>
+        </p:spPr>
+        <p:txBody>
+          <a:bodyPr wrap="square" rtlCol="0">
+            <a:spAutoFit/>
+          </a:bodyPr>
+          <a:lstStyle/>
+          <a:p>
+            <a:r>
+              <a:rPr lang="en-US" sz="1800" dirty="0"/>
+              <a:t>Rise and Fall of the OLAP Cubes:</a:t>
+            </a:r>
+          </a:p>
+          <a:p>
+            <a:r>
+              <a:rPr lang="en-US" dirty="0">
+                <a:hlinkClick r:id="rId6"/>
+              </a:rPr>
+              <a:t>https://www.holistics.io/blog/the-rise-and-fall-of-the-olap-cube/</a:t>
+            </a:r>
+            <a:r>
+              <a:rPr lang="en-US" dirty="0"/>
+              <a:t> </a:t>
+            </a:r>
+          </a:p>
+        </p:txBody>
+      </p:sp>
+      <p:sp>
+        <p:nvSpPr>
+          <p:cNvPr id="16" name="TextBox 15">
+            <a:extLst>
+              <a:ext uri="{FF2B5EF4-FFF2-40B4-BE49-F238E27FC236}">
+                <a16:creationId xmlns:a16="http://schemas.microsoft.com/office/drawing/2014/main" id="{1F06A897-448E-FC4A-91E6-06E28F891253}"/>
+              </a:ext>
+            </a:extLst>
+          </p:cNvPr>
+          <p:cNvSpPr txBox="1"/>
+          <p:nvPr/>
+        </p:nvSpPr>
+        <p:spPr>
+          <a:xfrm>
+            <a:off x="9002158" y="4218285"/>
+            <a:ext cx="3104389" cy="923330"/>
+          </a:xfrm>
+          <a:prstGeom prst="rect">
+            <a:avLst/>
+          </a:prstGeom>
+          <a:noFill/>
+        </p:spPr>
+        <p:txBody>
+          <a:bodyPr wrap="square" rtlCol="0">
+            <a:spAutoFit/>
+          </a:bodyPr>
+          <a:lstStyle/>
+          <a:p>
+            <a:pPr algn="ctr"/>
+            <a:r>
+              <a:rPr lang="en-US" sz="1800" b="1" dirty="0">
+                <a:solidFill>
+                  <a:srgbClr val="0070C0"/>
+                </a:solidFill>
+              </a:rPr>
+              <a:t>Interactive</a:t>
+            </a:r>
+          </a:p>
+          <a:p>
+            <a:pPr algn="ctr"/>
+            <a:r>
+              <a:rPr lang="en-US" sz="1800" b="1" dirty="0">
+                <a:solidFill>
+                  <a:srgbClr val="0070C0"/>
+                </a:solidFill>
+              </a:rPr>
+              <a:t>Dashboards</a:t>
+            </a:r>
+          </a:p>
+          <a:p>
+            <a:pPr algn="ctr"/>
+            <a:r>
+              <a:rPr lang="en-US" sz="1800" b="1" dirty="0">
+                <a:solidFill>
+                  <a:srgbClr val="0070C0"/>
+                </a:solidFill>
+              </a:rPr>
+              <a:t>(Power BI, Tableau, etc.)</a:t>
+            </a:r>
+            <a:endParaRPr lang="en-US" sz="1800" dirty="0"/>
+          </a:p>
+        </p:txBody>
+      </p:sp>
+    </p:spTree>
+    <p:extLst>
+      <p:ext uri="{BB962C8B-B14F-4D97-AF65-F5344CB8AC3E}">
+        <p14:creationId xmlns:p14="http://schemas.microsoft.com/office/powerpoint/2010/main" val="906584189"/>
+      </p:ext>
+    </p:extLst>
+  </p:cSld>
+  <p:clrMapOvr>
+    <a:masterClrMapping/>
+  </p:clrMapOvr>
+</p:sld>
+</file>
+
+<file path=ppt/slides/slide6.xml><?xml version="1.0" encoding="utf-8"?>
+<p:sld xmlns:a="http://schemas.openxmlformats.org/drawingml/2006/main" xmlns:r="http://schemas.openxmlformats.org/officeDocument/2006/relationships" xmlns:p="http://schemas.openxmlformats.org/presentationml/2006/main">
+  <p:cSld>
+    <p:spTree>
+      <p:nvGrpSpPr>
         <p:cNvPr id="1" name="Shape 109"/>
         <p:cNvGrpSpPr/>
         <p:nvPr/>
@@ -20021,7 +20789,49 @@
                 <a:cs typeface="Calibri"/>
                 <a:sym typeface="Calibri"/>
               </a:rPr>
-              <a:t>Databases can be optimized for OLTP (On-Line Transactional Processing) or OLAP (On-Line Analytical Processing). For analytics we need OLAP databases.</a:t>
+              <a:t>Databases can be optimized for </a:t>
+            </a:r>
+            <a:r>
+              <a:rPr lang="en-US" b="1" dirty="0">
+                <a:solidFill>
+                  <a:srgbClr val="0070C0"/>
+                </a:solidFill>
+                <a:latin typeface="Calibri"/>
+                <a:ea typeface="Calibri"/>
+                <a:cs typeface="Calibri"/>
+                <a:sym typeface="Calibri"/>
+              </a:rPr>
+              <a:t>OLTP (On-Line Transactional Processing)</a:t>
+            </a:r>
+            <a:r>
+              <a:rPr lang="en-US" dirty="0">
+                <a:latin typeface="Calibri"/>
+                <a:ea typeface="Calibri"/>
+                <a:cs typeface="Calibri"/>
+                <a:sym typeface="Calibri"/>
+              </a:rPr>
+              <a:t> or </a:t>
+            </a:r>
+            <a:r>
+              <a:rPr lang="en-US" b="1" dirty="0">
+                <a:solidFill>
+                  <a:srgbClr val="0070C0"/>
+                </a:solidFill>
+                <a:latin typeface="Calibri"/>
+                <a:ea typeface="Calibri"/>
+                <a:cs typeface="Calibri"/>
+                <a:sym typeface="Calibri"/>
+              </a:rPr>
+              <a:t>OLAP (On-Line Analytical Processing)</a:t>
+            </a:r>
+            <a:r>
+              <a:rPr lang="en-US" dirty="0">
+                <a:latin typeface="Calibri"/>
+                <a:ea typeface="Calibri"/>
+                <a:cs typeface="Calibri"/>
+                <a:sym typeface="Calibri"/>
+              </a:rPr>
+              <a:t>. For analytics we need OLAP databases.</a:t>
             </a:r>
             <a:endParaRPr dirty="0">
               <a:latin typeface="Calibri"/>
@@ -20174,16 +20984,7 @@
                 <a:cs typeface="Calibri"/>
                 <a:sym typeface="Calibri"/>
               </a:rPr>
-              <a:t> - https://</a:t>
-            </a:r>
-            <a:r>
-              <a:rPr lang="en-US" dirty="0" err="1">
-                <a:latin typeface="Calibri"/>
-                <a:ea typeface="Calibri"/>
-                <a:cs typeface="Calibri"/>
-                <a:sym typeface="Calibri"/>
-              </a:rPr>
-              <a:t>www.youtube.com</a:t>
+              <a:t> - </a:t>
             </a:r>
             <a:r>
               <a:rPr lang="en-US" dirty="0">
@@ -20191,17 +20992,9 @@
                 <a:ea typeface="Calibri"/>
                 <a:cs typeface="Calibri"/>
                 <a:sym typeface="Calibri"/>
-              </a:rPr>
-              <a:t>/</a:t>
-            </a:r>
-            <a:r>
-              <a:rPr lang="en-US" dirty="0" err="1">
-                <a:latin typeface="Calibri"/>
-                <a:ea typeface="Calibri"/>
-                <a:cs typeface="Calibri"/>
-                <a:sym typeface="Calibri"/>
-              </a:rPr>
-              <a:t>watch?v</a:t>
+                <a:hlinkClick r:id="rId3"/>
+              </a:rPr>
+              <a:t>https://www.youtube.com/watch?v=vPN8_PCsJm4</a:t>
             </a:r>
             <a:r>
               <a:rPr lang="en-US" dirty="0">
@@ -20210,7 +21003,7 @@
                 <a:cs typeface="Calibri"/>
                 <a:sym typeface="Calibri"/>
               </a:rPr>
-              <a:t>=vPN8_PCsJm4</a:t>
+              <a:t> </a:t>
             </a:r>
             <a:endParaRPr dirty="0">
               <a:latin typeface="Calibri"/>
@@ -20520,16 +21313,7 @@
                 <a:cs typeface="Calibri"/>
                 <a:sym typeface="Calibri"/>
               </a:rPr>
-              <a:t>- https://</a:t>
-            </a:r>
-            <a:r>
-              <a:rPr lang="en-US" dirty="0" err="1">
-                <a:latin typeface="Calibri"/>
-                <a:ea typeface="Calibri"/>
-                <a:cs typeface="Calibri"/>
-                <a:sym typeface="Calibri"/>
-              </a:rPr>
-              <a:t>azure.microsoft.com</a:t>
+              <a:t>- </a:t>
             </a:r>
             <a:r>
               <a:rPr lang="en-US" dirty="0">
@@ -20537,17 +21321,9 @@
                 <a:ea typeface="Calibri"/>
                 <a:cs typeface="Calibri"/>
                 <a:sym typeface="Calibri"/>
-              </a:rPr>
-              <a:t>/</a:t>
-            </a:r>
-            <a:r>
-              <a:rPr lang="en-US" dirty="0" err="1">
-                <a:latin typeface="Calibri"/>
-                <a:ea typeface="Calibri"/>
-                <a:cs typeface="Calibri"/>
-                <a:sym typeface="Calibri"/>
-              </a:rPr>
-              <a:t>en</a:t>
+                <a:hlinkClick r:id="rId4"/>
+              </a:rPr>
+              <a:t>https://azure.microsoft.com/en-us/services/sql-data-warehouse/</a:t>
             </a:r>
             <a:r>
               <a:rPr lang="en-US" dirty="0">
@@ -20556,25 +21332,7 @@
                 <a:cs typeface="Calibri"/>
                 <a:sym typeface="Calibri"/>
               </a:rPr>
-              <a:t>-us/services/</a:t>
-            </a:r>
-            <a:r>
-              <a:rPr lang="en-US" dirty="0" err="1">
-                <a:latin typeface="Calibri"/>
-                <a:ea typeface="Calibri"/>
-                <a:cs typeface="Calibri"/>
-                <a:sym typeface="Calibri"/>
-              </a:rPr>
-              <a:t>sql</a:t>
-            </a:r>
-            <a:r>
-              <a:rPr lang="en-US" dirty="0">
-                <a:latin typeface="Calibri"/>
-                <a:ea typeface="Calibri"/>
-                <a:cs typeface="Calibri"/>
-                <a:sym typeface="Calibri"/>
-              </a:rPr>
-              <a:t>-data-warehouse/</a:t>
+              <a:t> </a:t>
             </a:r>
           </a:p>
           <a:p>
@@ -20643,7 +21401,7 @@
             </a:r>
             <a:r>
               <a:rPr lang="en-US" dirty="0">
-                <a:hlinkClick r:id="rId3"/>
+                <a:hlinkClick r:id="rId5"/>
               </a:rPr>
               <a:t>https://en.wikipedia.org/wiki/Microsoft_Analysis_Services</a:t>
             </a:r>
@@ -20715,23 +21473,27 @@
                 <a:cs typeface="Calibri"/>
                 <a:sym typeface="Calibri"/>
               </a:rPr>
-              <a:t>- https://</a:t>
-            </a:r>
-            <a:r>
-              <a:rPr lang="en-US" dirty="0" err="1">
-                <a:latin typeface="Calibri"/>
-                <a:ea typeface="Calibri"/>
-                <a:cs typeface="Calibri"/>
-                <a:sym typeface="Calibri"/>
-              </a:rPr>
-              <a:t>powerbi.microsoft.com</a:t>
-            </a:r>
-            <a:endParaRPr lang="en-US" dirty="0">
-              <a:latin typeface="Calibri"/>
-              <a:ea typeface="Calibri"/>
-              <a:cs typeface="Calibri"/>
-              <a:sym typeface="Calibri"/>
-            </a:endParaRPr>
+              <a:t>- </a:t>
+            </a:r>
+            <a:r>
+              <a:rPr lang="en-US" dirty="0">
+                <a:latin typeface="Calibri"/>
+                <a:ea typeface="Calibri"/>
+                <a:cs typeface="Calibri"/>
+                <a:sym typeface="Calibri"/>
+                <a:hlinkClick r:id="rId6"/>
+              </a:rPr>
+              <a:t>https://powerbi.microsoft.com</a:t>
+            </a:r>
+            <a:r>
+              <a:rPr lang="en-US" dirty="0">
+                <a:latin typeface="Calibri"/>
+                <a:ea typeface="Calibri"/>
+                <a:cs typeface="Calibri"/>
+                <a:sym typeface="Calibri"/>
+              </a:rPr>
+              <a:t> </a:t>
+            </a:r>
           </a:p>
           <a:p>
             <a:pPr lvl="0">
@@ -20796,16 +21558,7 @@
                 <a:cs typeface="Calibri"/>
                 <a:sym typeface="Calibri"/>
               </a:rPr>
-              <a:t>- https://</a:t>
-            </a:r>
-            <a:r>
-              <a:rPr lang="en-US" dirty="0" err="1">
-                <a:latin typeface="Calibri"/>
-                <a:ea typeface="Calibri"/>
-                <a:cs typeface="Calibri"/>
-                <a:sym typeface="Calibri"/>
-              </a:rPr>
-              <a:t>www.youtube.com</a:t>
+              <a:t>- </a:t>
             </a:r>
             <a:r>
               <a:rPr lang="en-US" dirty="0">
@@ -20813,17 +21566,9 @@
                 <a:ea typeface="Calibri"/>
                 <a:cs typeface="Calibri"/>
                 <a:sym typeface="Calibri"/>
-              </a:rPr>
-              <a:t>/</a:t>
-            </a:r>
-            <a:r>
-              <a:rPr lang="en-US" dirty="0" err="1">
-                <a:latin typeface="Calibri"/>
-                <a:ea typeface="Calibri"/>
-                <a:cs typeface="Calibri"/>
-                <a:sym typeface="Calibri"/>
-              </a:rPr>
-              <a:t>watch?v</a:t>
+                <a:hlinkClick r:id="rId7"/>
+              </a:rPr>
+              <a:t>https://www.youtube.com/watch?v=mQyFp2MSl-s</a:t>
             </a:r>
             <a:r>
               <a:rPr lang="en-US" dirty="0">
@@ -20832,7 +21577,7 @@
                 <a:cs typeface="Calibri"/>
                 <a:sym typeface="Calibri"/>
               </a:rPr>
-              <a:t>=mQyFp2MSl-s</a:t>
+              <a:t> </a:t>
             </a:r>
           </a:p>
           <a:p>
@@ -20913,16 +21658,7 @@
                 <a:cs typeface="Calibri"/>
                 <a:sym typeface="Calibri"/>
               </a:rPr>
-              <a:t>- https://</a:t>
-            </a:r>
-            <a:r>
-              <a:rPr lang="en-US" dirty="0" err="1">
-                <a:latin typeface="Calibri"/>
-                <a:ea typeface="Calibri"/>
-                <a:cs typeface="Calibri"/>
-                <a:sym typeface="Calibri"/>
-              </a:rPr>
-              <a:t>www.youtube.com</a:t>
+              <a:t>- </a:t>
             </a:r>
             <a:r>
               <a:rPr lang="en-US" dirty="0">
@@ -20930,17 +21666,9 @@
                 <a:ea typeface="Calibri"/>
                 <a:cs typeface="Calibri"/>
                 <a:sym typeface="Calibri"/>
-              </a:rPr>
-              <a:t>/</a:t>
-            </a:r>
-            <a:r>
-              <a:rPr lang="en-US" dirty="0" err="1">
-                <a:latin typeface="Calibri"/>
-                <a:ea typeface="Calibri"/>
-                <a:cs typeface="Calibri"/>
-                <a:sym typeface="Calibri"/>
-              </a:rPr>
-              <a:t>watch?v</a:t>
+                <a:hlinkClick r:id="rId8"/>
+              </a:rPr>
+              <a:t>https://www.youtube.com/watch?v=7XliLU7ZC_s</a:t>
             </a:r>
             <a:r>
               <a:rPr lang="en-US" dirty="0">
@@ -20949,7 +21677,7 @@
                 <a:cs typeface="Calibri"/>
                 <a:sym typeface="Calibri"/>
               </a:rPr>
-              <a:t>=7XliLU7ZC_s</a:t>
+              <a:t> </a:t>
             </a:r>
             <a:endParaRPr dirty="0">
               <a:latin typeface="Calibri"/>
@@ -21246,870 +21974,6 @@
               <a:t>- you can enjoy lower prices</a:t>
             </a:r>
             <a:endParaRPr dirty="0">
-              <a:latin typeface="Calibri"/>
-              <a:ea typeface="Calibri"/>
-              <a:cs typeface="Calibri"/>
-              <a:sym typeface="Calibri"/>
-            </a:endParaRPr>
-          </a:p>
-        </p:txBody>
-      </p:sp>
-    </p:spTree>
-  </p:cSld>
-  <p:clrMapOvr>
-    <a:masterClrMapping/>
-  </p:clrMapOvr>
-</p:sld>
-</file>
-
-<file path=ppt/slides/slide6.xml><?xml version="1.0" encoding="utf-8"?>
-<p:sld xmlns:a="http://schemas.openxmlformats.org/drawingml/2006/main" xmlns:r="http://schemas.openxmlformats.org/officeDocument/2006/relationships" xmlns:p="http://schemas.openxmlformats.org/presentationml/2006/main">
-  <p:cSld>
-    <p:spTree>
-      <p:nvGrpSpPr>
-        <p:cNvPr id="1" name="Shape 116"/>
-        <p:cNvGrpSpPr/>
-        <p:nvPr/>
-      </p:nvGrpSpPr>
-      <p:grpSpPr>
-        <a:xfrm>
-          <a:off x="0" y="0"/>
-          <a:ext cx="0" cy="0"/>
-          <a:chOff x="0" y="0"/>
-          <a:chExt cx="0" cy="0"/>
-        </a:xfrm>
-      </p:grpSpPr>
-      <p:sp>
-        <p:nvSpPr>
-          <p:cNvPr id="117" name="Google Shape;117;p17"/>
-          <p:cNvSpPr txBox="1"/>
-          <p:nvPr/>
-        </p:nvSpPr>
-        <p:spPr>
-          <a:xfrm>
-            <a:off x="0" y="0"/>
-            <a:ext cx="6770700" cy="1988400"/>
-          </a:xfrm>
-          <a:prstGeom prst="rect">
-            <a:avLst/>
-          </a:prstGeom>
-          <a:noFill/>
-          <a:ln>
-            <a:noFill/>
-          </a:ln>
-        </p:spPr>
-        <p:txBody>
-          <a:bodyPr spcFirstLastPara="1" wrap="square" lIns="91425" tIns="91425" rIns="91425" bIns="91425" anchor="t" anchorCtr="0">
-            <a:noAutofit/>
-          </a:bodyPr>
-          <a:lstStyle/>
-          <a:p>
-            <a:pPr marL="0" lvl="0" indent="0" algn="l" rtl="0">
-              <a:spcBef>
-                <a:spcPts val="0"/>
-              </a:spcBef>
-              <a:spcAft>
-                <a:spcPts val="0"/>
-              </a:spcAft>
-              <a:buNone/>
-            </a:pPr>
-            <a:r>
-              <a:rPr lang="en-US" sz="2400" b="1" dirty="0">
-                <a:latin typeface="Calibri"/>
-                <a:ea typeface="Calibri"/>
-                <a:cs typeface="Calibri"/>
-                <a:sym typeface="Calibri"/>
-              </a:rPr>
-              <a:t>About Einstein Analytics (EA):</a:t>
-            </a:r>
-            <a:endParaRPr dirty="0">
-              <a:latin typeface="Calibri"/>
-              <a:ea typeface="Calibri"/>
-              <a:cs typeface="Calibri"/>
-              <a:sym typeface="Calibri"/>
-            </a:endParaRPr>
-          </a:p>
-          <a:p>
-            <a:pPr marL="0" lvl="0" indent="0" algn="l" rtl="0">
-              <a:spcBef>
-                <a:spcPts val="0"/>
-              </a:spcBef>
-              <a:spcAft>
-                <a:spcPts val="0"/>
-              </a:spcAft>
-              <a:buNone/>
-            </a:pPr>
-            <a:r>
-              <a:rPr lang="en-US" dirty="0">
-                <a:latin typeface="Calibri"/>
-                <a:ea typeface="Calibri"/>
-                <a:cs typeface="Calibri"/>
-                <a:sym typeface="Calibri"/>
-              </a:rPr>
-              <a:t>EA stores data not in regular SQL database, but in files and so called "inverted indexes" (II).</a:t>
-            </a:r>
-            <a:endParaRPr dirty="0">
-              <a:latin typeface="Calibri"/>
-              <a:ea typeface="Calibri"/>
-              <a:cs typeface="Calibri"/>
-              <a:sym typeface="Calibri"/>
-            </a:endParaRPr>
-          </a:p>
-          <a:p>
-            <a:pPr marL="0" lvl="0" indent="0" algn="l" rtl="0">
-              <a:spcBef>
-                <a:spcPts val="0"/>
-              </a:spcBef>
-              <a:spcAft>
-                <a:spcPts val="0"/>
-              </a:spcAft>
-              <a:buNone/>
-            </a:pPr>
-            <a:r>
-              <a:rPr lang="en-US" dirty="0">
-                <a:latin typeface="Calibri"/>
-                <a:ea typeface="Calibri"/>
-                <a:cs typeface="Calibri"/>
-                <a:sym typeface="Calibri"/>
-              </a:rPr>
-              <a:t>The motivation for selecting this technology was to have fast interactive data access.</a:t>
-            </a:r>
-            <a:endParaRPr dirty="0">
-              <a:latin typeface="Calibri"/>
-              <a:ea typeface="Calibri"/>
-              <a:cs typeface="Calibri"/>
-              <a:sym typeface="Calibri"/>
-            </a:endParaRPr>
-          </a:p>
-          <a:p>
-            <a:pPr marL="0" lvl="0" indent="0" algn="l" rtl="0">
-              <a:spcBef>
-                <a:spcPts val="0"/>
-              </a:spcBef>
-              <a:spcAft>
-                <a:spcPts val="0"/>
-              </a:spcAft>
-              <a:buNone/>
-            </a:pPr>
-            <a:r>
-              <a:rPr lang="en-US" dirty="0">
-                <a:latin typeface="Calibri"/>
-                <a:ea typeface="Calibri"/>
-                <a:cs typeface="Calibri"/>
-                <a:sym typeface="Calibri"/>
-              </a:rPr>
-              <a:t>The price to pay - the slowness of creating these "inverted indexes".</a:t>
-            </a:r>
-            <a:endParaRPr dirty="0">
-              <a:latin typeface="Calibri"/>
-              <a:ea typeface="Calibri"/>
-              <a:cs typeface="Calibri"/>
-              <a:sym typeface="Calibri"/>
-            </a:endParaRPr>
-          </a:p>
-          <a:p>
-            <a:pPr marL="0" lvl="0" indent="0" algn="l" rtl="0">
-              <a:spcBef>
-                <a:spcPts val="0"/>
-              </a:spcBef>
-              <a:spcAft>
-                <a:spcPts val="0"/>
-              </a:spcAft>
-              <a:buNone/>
-            </a:pPr>
-            <a:r>
-              <a:rPr lang="en-US" dirty="0">
-                <a:latin typeface="Calibri"/>
-                <a:ea typeface="Calibri"/>
-                <a:cs typeface="Calibri"/>
-                <a:sym typeface="Calibri"/>
-              </a:rPr>
-              <a:t>Every time you add data - you need to rebuild the whole index.</a:t>
-            </a:r>
-            <a:endParaRPr dirty="0">
-              <a:latin typeface="Calibri"/>
-              <a:ea typeface="Calibri"/>
-              <a:cs typeface="Calibri"/>
-              <a:sym typeface="Calibri"/>
-            </a:endParaRPr>
-          </a:p>
-          <a:p>
-            <a:pPr marL="0" lvl="0" indent="0" algn="l" rtl="0">
-              <a:spcBef>
-                <a:spcPts val="0"/>
-              </a:spcBef>
-              <a:spcAft>
-                <a:spcPts val="0"/>
-              </a:spcAft>
-              <a:buNone/>
-            </a:pPr>
-            <a:r>
-              <a:rPr lang="en-US" dirty="0">
-                <a:latin typeface="Calibri"/>
-                <a:ea typeface="Calibri"/>
-                <a:cs typeface="Calibri"/>
-                <a:sym typeface="Calibri"/>
-              </a:rPr>
-              <a:t>This article gives a nice explanation of what is II:</a:t>
-            </a:r>
-            <a:endParaRPr dirty="0">
-              <a:latin typeface="Calibri"/>
-              <a:ea typeface="Calibri"/>
-              <a:cs typeface="Calibri"/>
-              <a:sym typeface="Calibri"/>
-            </a:endParaRPr>
-          </a:p>
-          <a:p>
-            <a:pPr marL="0" lvl="0" indent="0" algn="l" rtl="0">
-              <a:spcBef>
-                <a:spcPts val="0"/>
-              </a:spcBef>
-              <a:spcAft>
-                <a:spcPts val="0"/>
-              </a:spcAft>
-              <a:buNone/>
-            </a:pPr>
-            <a:r>
-              <a:rPr lang="en-US" dirty="0">
-                <a:latin typeface="Calibri"/>
-                <a:ea typeface="Calibri"/>
-                <a:cs typeface="Calibri"/>
-                <a:sym typeface="Calibri"/>
-              </a:rPr>
-              <a:t> - https://</a:t>
-            </a:r>
-            <a:r>
-              <a:rPr lang="en-US" dirty="0" err="1">
-                <a:latin typeface="Calibri"/>
-                <a:ea typeface="Calibri"/>
-                <a:cs typeface="Calibri"/>
-                <a:sym typeface="Calibri"/>
-              </a:rPr>
-              <a:t>www.eternussolutions.com</a:t>
-            </a:r>
-            <a:r>
-              <a:rPr lang="en-US" dirty="0">
-                <a:latin typeface="Calibri"/>
-                <a:ea typeface="Calibri"/>
-                <a:cs typeface="Calibri"/>
-                <a:sym typeface="Calibri"/>
-              </a:rPr>
-              <a:t>/2016/11/13/10-things-love-wave-analytics/</a:t>
-            </a:r>
-            <a:endParaRPr dirty="0">
-              <a:latin typeface="Calibri"/>
-              <a:ea typeface="Calibri"/>
-              <a:cs typeface="Calibri"/>
-              <a:sym typeface="Calibri"/>
-            </a:endParaRPr>
-          </a:p>
-          <a:p>
-            <a:pPr marL="0" lvl="0" indent="0" algn="l" rtl="0">
-              <a:spcBef>
-                <a:spcPts val="0"/>
-              </a:spcBef>
-              <a:spcAft>
-                <a:spcPts val="0"/>
-              </a:spcAft>
-              <a:buNone/>
-            </a:pPr>
-            <a:r>
-              <a:rPr lang="en-US" dirty="0">
-                <a:latin typeface="Calibri"/>
-                <a:ea typeface="Calibri"/>
-                <a:cs typeface="Calibri"/>
-                <a:sym typeface="Calibri"/>
-              </a:rPr>
-              <a:t>And here is a picture showing the data - and its inverted index.</a:t>
-            </a:r>
-            <a:endParaRPr dirty="0">
-              <a:latin typeface="Calibri"/>
-              <a:ea typeface="Calibri"/>
-              <a:cs typeface="Calibri"/>
-              <a:sym typeface="Calibri"/>
-            </a:endParaRPr>
-          </a:p>
-        </p:txBody>
-      </p:sp>
-      <p:pic>
-        <p:nvPicPr>
-          <p:cNvPr id="118" name="Google Shape;118;p17"/>
-          <p:cNvPicPr preferRelativeResize="0"/>
-          <p:nvPr/>
-        </p:nvPicPr>
-        <p:blipFill>
-          <a:blip r:embed="rId3">
-            <a:alphaModFix/>
-          </a:blip>
-          <a:stretch>
-            <a:fillRect/>
-          </a:stretch>
-        </p:blipFill>
-        <p:spPr>
-          <a:xfrm>
-            <a:off x="311100" y="1988388"/>
-            <a:ext cx="6096000" cy="2752725"/>
-          </a:xfrm>
-          <a:prstGeom prst="rect">
-            <a:avLst/>
-          </a:prstGeom>
-          <a:noFill/>
-          <a:ln>
-            <a:noFill/>
-          </a:ln>
-        </p:spPr>
-      </p:pic>
-      <p:sp>
-        <p:nvSpPr>
-          <p:cNvPr id="119" name="Google Shape;119;p17"/>
-          <p:cNvSpPr txBox="1"/>
-          <p:nvPr/>
-        </p:nvSpPr>
-        <p:spPr>
-          <a:xfrm>
-            <a:off x="7207450" y="108700"/>
-            <a:ext cx="4911600" cy="4704600"/>
-          </a:xfrm>
-          <a:prstGeom prst="rect">
-            <a:avLst/>
-          </a:prstGeom>
-          <a:noFill/>
-          <a:ln>
-            <a:noFill/>
-          </a:ln>
-        </p:spPr>
-        <p:txBody>
-          <a:bodyPr spcFirstLastPara="1" wrap="square" lIns="91425" tIns="91425" rIns="91425" bIns="91425" anchor="t" anchorCtr="0">
-            <a:noAutofit/>
-          </a:bodyPr>
-          <a:lstStyle/>
-          <a:p>
-            <a:pPr marL="0" lvl="0" indent="0" algn="l" rtl="0">
-              <a:spcBef>
-                <a:spcPts val="0"/>
-              </a:spcBef>
-              <a:spcAft>
-                <a:spcPts val="0"/>
-              </a:spcAft>
-              <a:buNone/>
-            </a:pPr>
-            <a:r>
-              <a:rPr lang="en-US" dirty="0">
-                <a:latin typeface="Calibri"/>
-                <a:ea typeface="Calibri"/>
-                <a:cs typeface="Calibri"/>
-                <a:sym typeface="Calibri"/>
-              </a:rPr>
-              <a:t>I've first worked with an SQL database with compressed bitmap indexes in 2001-2002. The database was called "Sybase IQ".</a:t>
-            </a:r>
-            <a:endParaRPr dirty="0">
-              <a:latin typeface="Calibri"/>
-              <a:ea typeface="Calibri"/>
-              <a:cs typeface="Calibri"/>
-              <a:sym typeface="Calibri"/>
-            </a:endParaRPr>
-          </a:p>
-          <a:p>
-            <a:pPr marL="0" lvl="0" indent="0" algn="l" rtl="0">
-              <a:spcBef>
-                <a:spcPts val="0"/>
-              </a:spcBef>
-              <a:spcAft>
-                <a:spcPts val="0"/>
-              </a:spcAft>
-              <a:buNone/>
-            </a:pPr>
-            <a:r>
-              <a:rPr lang="en-US" dirty="0">
-                <a:latin typeface="Calibri"/>
-                <a:ea typeface="Calibri"/>
-                <a:cs typeface="Calibri"/>
-                <a:sym typeface="Calibri"/>
-              </a:rPr>
-              <a:t>It was an SQL database for doing analytics (as opposed to transactional processing).</a:t>
-            </a:r>
-            <a:endParaRPr dirty="0">
-              <a:latin typeface="Calibri"/>
-              <a:ea typeface="Calibri"/>
-              <a:cs typeface="Calibri"/>
-              <a:sym typeface="Calibri"/>
-            </a:endParaRPr>
-          </a:p>
-          <a:p>
-            <a:pPr marL="0" lvl="0" indent="0" algn="l" rtl="0">
-              <a:spcBef>
-                <a:spcPts val="0"/>
-              </a:spcBef>
-              <a:spcAft>
-                <a:spcPts val="0"/>
-              </a:spcAft>
-              <a:buNone/>
-            </a:pPr>
-            <a:endParaRPr dirty="0">
-              <a:latin typeface="Calibri"/>
-              <a:ea typeface="Calibri"/>
-              <a:cs typeface="Calibri"/>
-              <a:sym typeface="Calibri"/>
-            </a:endParaRPr>
-          </a:p>
-          <a:p>
-            <a:pPr marL="0" lvl="0" indent="0" algn="l" rtl="0">
-              <a:spcBef>
-                <a:spcPts val="0"/>
-              </a:spcBef>
-              <a:spcAft>
-                <a:spcPts val="0"/>
-              </a:spcAft>
-              <a:buNone/>
-            </a:pPr>
-            <a:r>
-              <a:rPr lang="en-US" dirty="0">
-                <a:latin typeface="Calibri"/>
-                <a:ea typeface="Calibri"/>
-                <a:cs typeface="Calibri"/>
-                <a:sym typeface="Calibri"/>
-              </a:rPr>
-              <a:t>Since then most SQL database vendors have adopted this "columnar" indexing. They switched from row-oriented storage and indexing to compressed column-oriented storage. </a:t>
-            </a:r>
-            <a:endParaRPr dirty="0">
-              <a:latin typeface="Calibri"/>
-              <a:ea typeface="Calibri"/>
-              <a:cs typeface="Calibri"/>
-              <a:sym typeface="Calibri"/>
-            </a:endParaRPr>
-          </a:p>
-          <a:p>
-            <a:pPr marL="0" lvl="0" indent="0" algn="l" rtl="0">
-              <a:spcBef>
-                <a:spcPts val="0"/>
-              </a:spcBef>
-              <a:spcAft>
-                <a:spcPts val="0"/>
-              </a:spcAft>
-              <a:buNone/>
-            </a:pPr>
-            <a:r>
-              <a:rPr lang="en-US" dirty="0">
-                <a:latin typeface="Calibri"/>
-                <a:ea typeface="Calibri"/>
-                <a:cs typeface="Calibri"/>
-                <a:sym typeface="Calibri"/>
-              </a:rPr>
-              <a:t>This is basically equivalent to the "Inverted Index" idea.</a:t>
-            </a:r>
-            <a:endParaRPr dirty="0">
-              <a:latin typeface="Calibri"/>
-              <a:ea typeface="Calibri"/>
-              <a:cs typeface="Calibri"/>
-              <a:sym typeface="Calibri"/>
-            </a:endParaRPr>
-          </a:p>
-          <a:p>
-            <a:pPr marL="0" lvl="0" indent="0" algn="l" rtl="0">
-              <a:spcBef>
-                <a:spcPts val="0"/>
-              </a:spcBef>
-              <a:spcAft>
-                <a:spcPts val="0"/>
-              </a:spcAft>
-              <a:buNone/>
-            </a:pPr>
-            <a:endParaRPr dirty="0">
-              <a:latin typeface="Calibri"/>
-              <a:ea typeface="Calibri"/>
-              <a:cs typeface="Calibri"/>
-              <a:sym typeface="Calibri"/>
-            </a:endParaRPr>
-          </a:p>
-          <a:p>
-            <a:pPr marL="0" lvl="0" indent="0" algn="l" rtl="0">
-              <a:spcBef>
-                <a:spcPts val="0"/>
-              </a:spcBef>
-              <a:spcAft>
-                <a:spcPts val="0"/>
-              </a:spcAft>
-              <a:buNone/>
-            </a:pPr>
-            <a:r>
-              <a:rPr lang="en-US" dirty="0">
-                <a:latin typeface="Calibri"/>
-                <a:ea typeface="Calibri"/>
-                <a:cs typeface="Calibri"/>
-                <a:sym typeface="Calibri"/>
-              </a:rPr>
-              <a:t>Modern SQL databases can provide performance much faster than EA. You just need to select an implementation with appropriate characteristics.</a:t>
-            </a:r>
-            <a:endParaRPr dirty="0">
-              <a:latin typeface="Calibri"/>
-              <a:ea typeface="Calibri"/>
-              <a:cs typeface="Calibri"/>
-              <a:sym typeface="Calibri"/>
-            </a:endParaRPr>
-          </a:p>
-          <a:p>
-            <a:pPr marL="0" lvl="0" indent="0" algn="l" rtl="0">
-              <a:spcBef>
-                <a:spcPts val="0"/>
-              </a:spcBef>
-              <a:spcAft>
-                <a:spcPts val="0"/>
-              </a:spcAft>
-              <a:buNone/>
-            </a:pPr>
-            <a:endParaRPr dirty="0">
-              <a:latin typeface="Calibri"/>
-              <a:ea typeface="Calibri"/>
-              <a:cs typeface="Calibri"/>
-              <a:sym typeface="Calibri"/>
-            </a:endParaRPr>
-          </a:p>
-          <a:p>
-            <a:pPr marL="0" lvl="0" indent="0" algn="l" rtl="0">
-              <a:spcBef>
-                <a:spcPts val="0"/>
-              </a:spcBef>
-              <a:spcAft>
-                <a:spcPts val="0"/>
-              </a:spcAft>
-              <a:buNone/>
-            </a:pPr>
-            <a:r>
-              <a:rPr lang="en-US" dirty="0">
-                <a:latin typeface="Calibri"/>
-                <a:ea typeface="Calibri"/>
-                <a:cs typeface="Calibri"/>
-                <a:sym typeface="Calibri"/>
-              </a:rPr>
-              <a:t>For example, on AWS (or other clouds) you can select a GPU-based SQL database on a server with terabytes of memory.</a:t>
-            </a:r>
-            <a:endParaRPr dirty="0">
-              <a:latin typeface="Calibri"/>
-              <a:ea typeface="Calibri"/>
-              <a:cs typeface="Calibri"/>
-              <a:sym typeface="Calibri"/>
-            </a:endParaRPr>
-          </a:p>
-          <a:p>
-            <a:pPr marL="0" lvl="0" indent="0" algn="l" rtl="0">
-              <a:spcBef>
-                <a:spcPts val="0"/>
-              </a:spcBef>
-              <a:spcAft>
-                <a:spcPts val="0"/>
-              </a:spcAft>
-              <a:buNone/>
-            </a:pPr>
-            <a:r>
-              <a:rPr lang="en-US" dirty="0">
-                <a:latin typeface="Calibri"/>
-                <a:ea typeface="Calibri"/>
-                <a:cs typeface="Calibri"/>
-                <a:sym typeface="Calibri"/>
-              </a:rPr>
-              <a:t>This database can query the data and give updates with a speed of a live movie (milliseconds).</a:t>
-            </a:r>
-            <a:endParaRPr dirty="0">
-              <a:latin typeface="Calibri"/>
-              <a:ea typeface="Calibri"/>
-              <a:cs typeface="Calibri"/>
-              <a:sym typeface="Calibri"/>
-            </a:endParaRPr>
-          </a:p>
-          <a:p>
-            <a:pPr marL="0" lvl="0" indent="0" algn="l" rtl="0">
-              <a:spcBef>
-                <a:spcPts val="0"/>
-              </a:spcBef>
-              <a:spcAft>
-                <a:spcPts val="0"/>
-              </a:spcAft>
-              <a:buNone/>
-            </a:pPr>
-            <a:r>
-              <a:rPr lang="en-US" dirty="0">
-                <a:latin typeface="Calibri"/>
-                <a:ea typeface="Calibri"/>
-                <a:cs typeface="Calibri"/>
-                <a:sym typeface="Calibri"/>
-              </a:rPr>
-              <a:t>And we can still use conventional ETL tools and enjoy fast data load speeds.</a:t>
-            </a:r>
-            <a:endParaRPr dirty="0">
-              <a:latin typeface="Calibri"/>
-              <a:ea typeface="Calibri"/>
-              <a:cs typeface="Calibri"/>
-              <a:sym typeface="Calibri"/>
-            </a:endParaRPr>
-          </a:p>
-          <a:p>
-            <a:pPr marL="0" lvl="0" indent="0" algn="l" rtl="0">
-              <a:spcBef>
-                <a:spcPts val="0"/>
-              </a:spcBef>
-              <a:spcAft>
-                <a:spcPts val="0"/>
-              </a:spcAft>
-              <a:buNone/>
-            </a:pPr>
-            <a:r>
-              <a:rPr lang="en-US" dirty="0">
-                <a:latin typeface="Calibri"/>
-                <a:ea typeface="Calibri"/>
-                <a:cs typeface="Calibri"/>
-                <a:sym typeface="Calibri"/>
-              </a:rPr>
-              <a:t>And it will be probably cheaper than EA.</a:t>
-            </a:r>
-            <a:endParaRPr dirty="0">
-              <a:latin typeface="Calibri"/>
-              <a:ea typeface="Calibri"/>
-              <a:cs typeface="Calibri"/>
-              <a:sym typeface="Calibri"/>
-            </a:endParaRPr>
-          </a:p>
-        </p:txBody>
-      </p:sp>
-      <p:sp>
-        <p:nvSpPr>
-          <p:cNvPr id="120" name="Google Shape;120;p17"/>
-          <p:cNvSpPr txBox="1"/>
-          <p:nvPr/>
-        </p:nvSpPr>
-        <p:spPr>
-          <a:xfrm>
-            <a:off x="0" y="4813150"/>
-            <a:ext cx="7125000" cy="1543500"/>
-          </a:xfrm>
-          <a:prstGeom prst="rect">
-            <a:avLst/>
-          </a:prstGeom>
-          <a:noFill/>
-          <a:ln>
-            <a:noFill/>
-          </a:ln>
-        </p:spPr>
-        <p:txBody>
-          <a:bodyPr spcFirstLastPara="1" wrap="square" lIns="91425" tIns="91425" rIns="91425" bIns="91425" anchor="t" anchorCtr="0">
-            <a:noAutofit/>
-          </a:bodyPr>
-          <a:lstStyle/>
-          <a:p>
-            <a:pPr marL="0" lvl="0" indent="0" algn="l" rtl="0">
-              <a:spcBef>
-                <a:spcPts val="0"/>
-              </a:spcBef>
-              <a:spcAft>
-                <a:spcPts val="0"/>
-              </a:spcAft>
-              <a:buNone/>
-            </a:pPr>
-            <a:r>
-              <a:rPr lang="en-US">
-                <a:latin typeface="Calibri"/>
-                <a:ea typeface="Calibri"/>
-                <a:cs typeface="Calibri"/>
-                <a:sym typeface="Calibri"/>
-              </a:rPr>
-              <a:t>Inverted indexes are usually implemented as compressed bitmaps - and cached in memory.</a:t>
-            </a:r>
-            <a:endParaRPr>
-              <a:latin typeface="Calibri"/>
-              <a:ea typeface="Calibri"/>
-              <a:cs typeface="Calibri"/>
-              <a:sym typeface="Calibri"/>
-            </a:endParaRPr>
-          </a:p>
-          <a:p>
-            <a:pPr marL="0" lvl="0" indent="0" algn="l" rtl="0">
-              <a:spcBef>
-                <a:spcPts val="0"/>
-              </a:spcBef>
-              <a:spcAft>
-                <a:spcPts val="0"/>
-              </a:spcAft>
-              <a:buNone/>
-            </a:pPr>
-            <a:r>
-              <a:rPr lang="en-US">
-                <a:latin typeface="Calibri"/>
-                <a:ea typeface="Calibri"/>
-                <a:cs typeface="Calibri"/>
-                <a:sym typeface="Calibri"/>
-              </a:rPr>
-              <a:t>They may be also implemented as "conventional" trees.</a:t>
-            </a:r>
-            <a:endParaRPr>
-              <a:latin typeface="Calibri"/>
-              <a:ea typeface="Calibri"/>
-              <a:cs typeface="Calibri"/>
-              <a:sym typeface="Calibri"/>
-            </a:endParaRPr>
-          </a:p>
-          <a:p>
-            <a:pPr marL="0" lvl="0" indent="0" algn="l" rtl="0">
-              <a:spcBef>
-                <a:spcPts val="0"/>
-              </a:spcBef>
-              <a:spcAft>
-                <a:spcPts val="0"/>
-              </a:spcAft>
-              <a:buNone/>
-            </a:pPr>
-            <a:r>
-              <a:rPr lang="en-US">
-                <a:latin typeface="Calibri"/>
-                <a:ea typeface="Calibri"/>
-                <a:cs typeface="Calibri"/>
-                <a:sym typeface="Calibri"/>
-              </a:rPr>
-              <a:t>Here are more links about Inverted indexes:</a:t>
-            </a:r>
-            <a:endParaRPr>
-              <a:latin typeface="Calibri"/>
-              <a:ea typeface="Calibri"/>
-              <a:cs typeface="Calibri"/>
-              <a:sym typeface="Calibri"/>
-            </a:endParaRPr>
-          </a:p>
-          <a:p>
-            <a:pPr marL="0" lvl="0" indent="0" algn="l" rtl="0">
-              <a:spcBef>
-                <a:spcPts val="0"/>
-              </a:spcBef>
-              <a:spcAft>
-                <a:spcPts val="0"/>
-              </a:spcAft>
-              <a:buNone/>
-            </a:pPr>
-            <a:r>
-              <a:rPr lang="en-US" sz="1100">
-                <a:latin typeface="Calibri"/>
-                <a:ea typeface="Calibri"/>
-                <a:cs typeface="Calibri"/>
-                <a:sym typeface="Calibri"/>
-              </a:rPr>
-              <a:t>- </a:t>
-            </a:r>
-            <a:r>
-              <a:rPr lang="en-US" sz="1100" u="sng">
-                <a:solidFill>
-                  <a:schemeClr val="hlink"/>
-                </a:solidFill>
-                <a:latin typeface="Calibri"/>
-                <a:ea typeface="Calibri"/>
-                <a:cs typeface="Calibri"/>
-                <a:sym typeface="Calibri"/>
-                <a:hlinkClick r:id="rId4"/>
-              </a:rPr>
-              <a:t>https://www.quora.com/In-database-design-what-exactly-is-the-difference-between-inverted-index-and-a-normal-index</a:t>
-            </a:r>
-            <a:r>
-              <a:rPr lang="en-US" sz="1100">
-                <a:latin typeface="Calibri"/>
-                <a:ea typeface="Calibri"/>
-                <a:cs typeface="Calibri"/>
-                <a:sym typeface="Calibri"/>
-              </a:rPr>
-              <a:t> </a:t>
-            </a:r>
-            <a:endParaRPr sz="1100">
-              <a:latin typeface="Calibri"/>
-              <a:ea typeface="Calibri"/>
-              <a:cs typeface="Calibri"/>
-              <a:sym typeface="Calibri"/>
-            </a:endParaRPr>
-          </a:p>
-          <a:p>
-            <a:pPr marL="0" lvl="0" indent="0" algn="l" rtl="0">
-              <a:spcBef>
-                <a:spcPts val="0"/>
-              </a:spcBef>
-              <a:spcAft>
-                <a:spcPts val="0"/>
-              </a:spcAft>
-              <a:buNone/>
-            </a:pPr>
-            <a:r>
-              <a:rPr lang="en-US" sz="1100">
-                <a:latin typeface="Calibri"/>
-                <a:ea typeface="Calibri"/>
-                <a:cs typeface="Calibri"/>
-                <a:sym typeface="Calibri"/>
-              </a:rPr>
-              <a:t>- </a:t>
-            </a:r>
-            <a:r>
-              <a:rPr lang="en-US" sz="1100" u="sng">
-                <a:solidFill>
-                  <a:schemeClr val="hlink"/>
-                </a:solidFill>
-                <a:latin typeface="Calibri"/>
-                <a:ea typeface="Calibri"/>
-                <a:cs typeface="Calibri"/>
-                <a:sym typeface="Calibri"/>
-                <a:hlinkClick r:id="rId5"/>
-              </a:rPr>
-              <a:t>https://stackoverflow.com/questions/47537318/b-tree-index-vs-inverted-index</a:t>
-            </a:r>
-            <a:r>
-              <a:rPr lang="en-US" sz="1100">
-                <a:latin typeface="Calibri"/>
-                <a:ea typeface="Calibri"/>
-                <a:cs typeface="Calibri"/>
-                <a:sym typeface="Calibri"/>
-              </a:rPr>
-              <a:t> </a:t>
-            </a:r>
-            <a:endParaRPr sz="1100">
-              <a:latin typeface="Calibri"/>
-              <a:ea typeface="Calibri"/>
-              <a:cs typeface="Calibri"/>
-              <a:sym typeface="Calibri"/>
-            </a:endParaRPr>
-          </a:p>
-          <a:p>
-            <a:pPr marL="0" lvl="0" indent="0" algn="l" rtl="0">
-              <a:spcBef>
-                <a:spcPts val="0"/>
-              </a:spcBef>
-              <a:spcAft>
-                <a:spcPts val="0"/>
-              </a:spcAft>
-              <a:buNone/>
-            </a:pPr>
-            <a:r>
-              <a:rPr lang="en-US" sz="1100">
-                <a:latin typeface="Calibri"/>
-                <a:ea typeface="Calibri"/>
-                <a:cs typeface="Calibri"/>
-                <a:sym typeface="Calibri"/>
-              </a:rPr>
-              <a:t>- </a:t>
-            </a:r>
-            <a:r>
-              <a:rPr lang="en-US" sz="1100" u="sng">
-                <a:solidFill>
-                  <a:schemeClr val="hlink"/>
-                </a:solidFill>
-                <a:latin typeface="Calibri"/>
-                <a:ea typeface="Calibri"/>
-                <a:cs typeface="Calibri"/>
-                <a:sym typeface="Calibri"/>
-                <a:hlinkClick r:id="rId6"/>
-              </a:rPr>
-              <a:t>https://en.wikipedia.org/wiki/Inverted_index</a:t>
-            </a:r>
-            <a:r>
-              <a:rPr lang="en-US" sz="1100">
-                <a:latin typeface="Calibri"/>
-                <a:ea typeface="Calibri"/>
-                <a:cs typeface="Calibri"/>
-                <a:sym typeface="Calibri"/>
-              </a:rPr>
-              <a:t> </a:t>
-            </a:r>
-            <a:endParaRPr>
               <a:latin typeface="Calibri"/>
               <a:ea typeface="Calibri"/>
               <a:cs typeface="Calibri"/>
@@ -22691,6 +22555,977 @@
         <p14:creationId xmlns:p14="http://schemas.microsoft.com/office/powerpoint/2010/main" val="1515266594"/>
       </p:ext>
     </p:extLst>
+  </p:cSld>
+  <p:clrMapOvr>
+    <a:masterClrMapping/>
+  </p:clrMapOvr>
+</p:sld>
+</file>
+
+<file path=ppt/slides/slide8.xml><?xml version="1.0" encoding="utf-8"?>
+<p:sld xmlns:a="http://schemas.openxmlformats.org/drawingml/2006/main" xmlns:r="http://schemas.openxmlformats.org/officeDocument/2006/relationships" xmlns:p="http://schemas.openxmlformats.org/presentationml/2006/main">
+  <p:cSld>
+    <p:spTree>
+      <p:nvGrpSpPr>
+        <p:cNvPr id="1" name="Shape 116"/>
+        <p:cNvGrpSpPr/>
+        <p:nvPr/>
+      </p:nvGrpSpPr>
+      <p:grpSpPr>
+        <a:xfrm>
+          <a:off x="0" y="0"/>
+          <a:ext cx="0" cy="0"/>
+          <a:chOff x="0" y="0"/>
+          <a:chExt cx="0" cy="0"/>
+        </a:xfrm>
+      </p:grpSpPr>
+      <p:sp>
+        <p:nvSpPr>
+          <p:cNvPr id="117" name="Google Shape;117;p17"/>
+          <p:cNvSpPr txBox="1"/>
+          <p:nvPr/>
+        </p:nvSpPr>
+        <p:spPr>
+          <a:xfrm>
+            <a:off x="100016" y="0"/>
+            <a:ext cx="6770700" cy="2286000"/>
+          </a:xfrm>
+          <a:prstGeom prst="rect">
+            <a:avLst/>
+          </a:prstGeom>
+          <a:noFill/>
+          <a:ln>
+            <a:noFill/>
+          </a:ln>
+        </p:spPr>
+        <p:txBody>
+          <a:bodyPr spcFirstLastPara="1" wrap="square" lIns="91425" tIns="91425" rIns="91425" bIns="91425" anchor="t" anchorCtr="0">
+            <a:noAutofit/>
+          </a:bodyPr>
+          <a:lstStyle/>
+          <a:p>
+            <a:pPr marL="0" lvl="0" indent="0" algn="l" rtl="0">
+              <a:spcBef>
+                <a:spcPts val="0"/>
+              </a:spcBef>
+              <a:spcAft>
+                <a:spcPts val="0"/>
+              </a:spcAft>
+              <a:buNone/>
+            </a:pPr>
+            <a:r>
+              <a:rPr lang="en-US" sz="2400" b="1" dirty="0">
+                <a:latin typeface="Calibri"/>
+                <a:ea typeface="Calibri"/>
+                <a:cs typeface="Calibri"/>
+                <a:sym typeface="Calibri"/>
+              </a:rPr>
+              <a:t>Inverted Indexes:</a:t>
+            </a:r>
+            <a:endParaRPr dirty="0">
+              <a:latin typeface="Calibri"/>
+              <a:ea typeface="Calibri"/>
+              <a:cs typeface="Calibri"/>
+              <a:sym typeface="Calibri"/>
+            </a:endParaRPr>
+          </a:p>
+          <a:p>
+            <a:pPr marL="0" lvl="0" indent="0" algn="l" rtl="0">
+              <a:spcBef>
+                <a:spcPts val="0"/>
+              </a:spcBef>
+              <a:spcAft>
+                <a:spcPts val="0"/>
+              </a:spcAft>
+              <a:buNone/>
+            </a:pPr>
+            <a:r>
+              <a:rPr lang="en-US" dirty="0">
+                <a:latin typeface="Calibri"/>
+                <a:ea typeface="Calibri"/>
+                <a:cs typeface="Calibri"/>
+                <a:sym typeface="Calibri"/>
+              </a:rPr>
+              <a:t>Salesforce Einstein Analytics stores data not in regular SQL database, but in files and so called "inverted indexes" (II).</a:t>
+            </a:r>
+            <a:endParaRPr dirty="0">
+              <a:latin typeface="Calibri"/>
+              <a:ea typeface="Calibri"/>
+              <a:cs typeface="Calibri"/>
+              <a:sym typeface="Calibri"/>
+            </a:endParaRPr>
+          </a:p>
+          <a:p>
+            <a:pPr marL="0" lvl="0" indent="0" algn="l" rtl="0">
+              <a:spcBef>
+                <a:spcPts val="0"/>
+              </a:spcBef>
+              <a:spcAft>
+                <a:spcPts val="0"/>
+              </a:spcAft>
+              <a:buNone/>
+            </a:pPr>
+            <a:r>
+              <a:rPr lang="en-US" dirty="0">
+                <a:latin typeface="Calibri"/>
+                <a:ea typeface="Calibri"/>
+                <a:cs typeface="Calibri"/>
+                <a:sym typeface="Calibri"/>
+              </a:rPr>
+              <a:t>The motivation for selecting this technology was to have fast interactive data access.</a:t>
+            </a:r>
+            <a:endParaRPr dirty="0">
+              <a:latin typeface="Calibri"/>
+              <a:ea typeface="Calibri"/>
+              <a:cs typeface="Calibri"/>
+              <a:sym typeface="Calibri"/>
+            </a:endParaRPr>
+          </a:p>
+          <a:p>
+            <a:pPr marL="0" lvl="0" indent="0" algn="l" rtl="0">
+              <a:spcBef>
+                <a:spcPts val="0"/>
+              </a:spcBef>
+              <a:spcAft>
+                <a:spcPts val="0"/>
+              </a:spcAft>
+              <a:buNone/>
+            </a:pPr>
+            <a:r>
+              <a:rPr lang="en-US" dirty="0">
+                <a:latin typeface="Calibri"/>
+                <a:ea typeface="Calibri"/>
+                <a:cs typeface="Calibri"/>
+                <a:sym typeface="Calibri"/>
+              </a:rPr>
+              <a:t>The price to pay - the slowness of creating these "inverted indexes".</a:t>
+            </a:r>
+            <a:endParaRPr dirty="0">
+              <a:latin typeface="Calibri"/>
+              <a:ea typeface="Calibri"/>
+              <a:cs typeface="Calibri"/>
+              <a:sym typeface="Calibri"/>
+            </a:endParaRPr>
+          </a:p>
+          <a:p>
+            <a:pPr marL="0" lvl="0" indent="0" algn="l" rtl="0">
+              <a:spcBef>
+                <a:spcPts val="0"/>
+              </a:spcBef>
+              <a:spcAft>
+                <a:spcPts val="0"/>
+              </a:spcAft>
+              <a:buNone/>
+            </a:pPr>
+            <a:r>
+              <a:rPr lang="en-US" dirty="0">
+                <a:latin typeface="Calibri"/>
+                <a:ea typeface="Calibri"/>
+                <a:cs typeface="Calibri"/>
+                <a:sym typeface="Calibri"/>
+              </a:rPr>
+              <a:t>Every time you add data - you need to rebuild the whole index.</a:t>
+            </a:r>
+            <a:endParaRPr dirty="0">
+              <a:latin typeface="Calibri"/>
+              <a:ea typeface="Calibri"/>
+              <a:cs typeface="Calibri"/>
+              <a:sym typeface="Calibri"/>
+            </a:endParaRPr>
+          </a:p>
+          <a:p>
+            <a:pPr marL="0" lvl="0" indent="0" algn="l" rtl="0">
+              <a:spcBef>
+                <a:spcPts val="0"/>
+              </a:spcBef>
+              <a:spcAft>
+                <a:spcPts val="0"/>
+              </a:spcAft>
+              <a:buNone/>
+            </a:pPr>
+            <a:r>
+              <a:rPr lang="en-US" dirty="0">
+                <a:latin typeface="Calibri"/>
+                <a:ea typeface="Calibri"/>
+                <a:cs typeface="Calibri"/>
+                <a:sym typeface="Calibri"/>
+              </a:rPr>
+              <a:t>This article gives a nice explanation of what is II:</a:t>
+            </a:r>
+            <a:endParaRPr dirty="0">
+              <a:latin typeface="Calibri"/>
+              <a:ea typeface="Calibri"/>
+              <a:cs typeface="Calibri"/>
+              <a:sym typeface="Calibri"/>
+            </a:endParaRPr>
+          </a:p>
+          <a:p>
+            <a:pPr marL="0" lvl="0" indent="0" algn="l" rtl="0">
+              <a:spcBef>
+                <a:spcPts val="0"/>
+              </a:spcBef>
+              <a:spcAft>
+                <a:spcPts val="0"/>
+              </a:spcAft>
+              <a:buNone/>
+            </a:pPr>
+            <a:r>
+              <a:rPr lang="en-US" dirty="0">
+                <a:latin typeface="Calibri"/>
+                <a:ea typeface="Calibri"/>
+                <a:cs typeface="Calibri"/>
+                <a:sym typeface="Calibri"/>
+              </a:rPr>
+              <a:t> - https://</a:t>
+            </a:r>
+            <a:r>
+              <a:rPr lang="en-US" dirty="0" err="1">
+                <a:latin typeface="Calibri"/>
+                <a:ea typeface="Calibri"/>
+                <a:cs typeface="Calibri"/>
+                <a:sym typeface="Calibri"/>
+              </a:rPr>
+              <a:t>www.eternussolutions.com</a:t>
+            </a:r>
+            <a:r>
+              <a:rPr lang="en-US" dirty="0">
+                <a:latin typeface="Calibri"/>
+                <a:ea typeface="Calibri"/>
+                <a:cs typeface="Calibri"/>
+                <a:sym typeface="Calibri"/>
+              </a:rPr>
+              <a:t>/2016/11/13/10-things-love-wave-analytics/</a:t>
+            </a:r>
+            <a:endParaRPr dirty="0">
+              <a:latin typeface="Calibri"/>
+              <a:ea typeface="Calibri"/>
+              <a:cs typeface="Calibri"/>
+              <a:sym typeface="Calibri"/>
+            </a:endParaRPr>
+          </a:p>
+          <a:p>
+            <a:pPr marL="0" lvl="0" indent="0" algn="l" rtl="0">
+              <a:spcBef>
+                <a:spcPts val="0"/>
+              </a:spcBef>
+              <a:spcAft>
+                <a:spcPts val="0"/>
+              </a:spcAft>
+              <a:buNone/>
+            </a:pPr>
+            <a:r>
+              <a:rPr lang="en-US" dirty="0">
+                <a:latin typeface="Calibri"/>
+                <a:ea typeface="Calibri"/>
+                <a:cs typeface="Calibri"/>
+                <a:sym typeface="Calibri"/>
+              </a:rPr>
+              <a:t>And here is a picture showing the data - and its inverted index.</a:t>
+            </a:r>
+            <a:endParaRPr dirty="0">
+              <a:latin typeface="Calibri"/>
+              <a:ea typeface="Calibri"/>
+              <a:cs typeface="Calibri"/>
+              <a:sym typeface="Calibri"/>
+            </a:endParaRPr>
+          </a:p>
+        </p:txBody>
+      </p:sp>
+      <p:pic>
+        <p:nvPicPr>
+          <p:cNvPr id="118" name="Google Shape;118;p17"/>
+          <p:cNvPicPr preferRelativeResize="0"/>
+          <p:nvPr/>
+        </p:nvPicPr>
+        <p:blipFill>
+          <a:blip r:embed="rId3">
+            <a:alphaModFix/>
+          </a:blip>
+          <a:stretch>
+            <a:fillRect/>
+          </a:stretch>
+        </p:blipFill>
+        <p:spPr>
+          <a:xfrm>
+            <a:off x="511128" y="2474170"/>
+            <a:ext cx="6096000" cy="2752725"/>
+          </a:xfrm>
+          <a:prstGeom prst="rect">
+            <a:avLst/>
+          </a:prstGeom>
+          <a:noFill/>
+          <a:ln>
+            <a:noFill/>
+          </a:ln>
+        </p:spPr>
+      </p:pic>
+      <p:sp>
+        <p:nvSpPr>
+          <p:cNvPr id="119" name="Google Shape;119;p17"/>
+          <p:cNvSpPr txBox="1"/>
+          <p:nvPr/>
+        </p:nvSpPr>
+        <p:spPr>
+          <a:xfrm>
+            <a:off x="7207450" y="108700"/>
+            <a:ext cx="4911600" cy="4877638"/>
+          </a:xfrm>
+          <a:prstGeom prst="rect">
+            <a:avLst/>
+          </a:prstGeom>
+          <a:noFill/>
+          <a:ln>
+            <a:noFill/>
+          </a:ln>
+        </p:spPr>
+        <p:txBody>
+          <a:bodyPr spcFirstLastPara="1" wrap="square" lIns="91425" tIns="91425" rIns="91425" bIns="91425" anchor="t" anchorCtr="0">
+            <a:noAutofit/>
+          </a:bodyPr>
+          <a:lstStyle/>
+          <a:p>
+            <a:pPr marL="0" lvl="0" indent="0" algn="l" rtl="0">
+              <a:spcBef>
+                <a:spcPts val="0"/>
+              </a:spcBef>
+              <a:spcAft>
+                <a:spcPts val="0"/>
+              </a:spcAft>
+              <a:buNone/>
+            </a:pPr>
+            <a:r>
+              <a:rPr lang="en-US" dirty="0">
+                <a:latin typeface="Calibri"/>
+                <a:ea typeface="Calibri"/>
+                <a:cs typeface="Calibri"/>
+                <a:sym typeface="Calibri"/>
+              </a:rPr>
+              <a:t>I've first worked with an SQL database with compressed bitmap indexes in 2001-2002. The database was called "</a:t>
+            </a:r>
+            <a:r>
+              <a:rPr lang="en-US" b="1" dirty="0">
+                <a:solidFill>
+                  <a:srgbClr val="0070C0"/>
+                </a:solidFill>
+                <a:latin typeface="Calibri"/>
+                <a:ea typeface="Calibri"/>
+                <a:cs typeface="Calibri"/>
+                <a:sym typeface="Calibri"/>
+              </a:rPr>
+              <a:t>Sybase IQ</a:t>
+            </a:r>
+            <a:r>
+              <a:rPr lang="en-US" dirty="0">
+                <a:latin typeface="Calibri"/>
+                <a:ea typeface="Calibri"/>
+                <a:cs typeface="Calibri"/>
+                <a:sym typeface="Calibri"/>
+              </a:rPr>
+              <a:t>".</a:t>
+            </a:r>
+            <a:endParaRPr dirty="0">
+              <a:latin typeface="Calibri"/>
+              <a:ea typeface="Calibri"/>
+              <a:cs typeface="Calibri"/>
+              <a:sym typeface="Calibri"/>
+            </a:endParaRPr>
+          </a:p>
+          <a:p>
+            <a:pPr marL="0" lvl="0" indent="0" algn="l" rtl="0">
+              <a:spcBef>
+                <a:spcPts val="0"/>
+              </a:spcBef>
+              <a:spcAft>
+                <a:spcPts val="0"/>
+              </a:spcAft>
+              <a:buNone/>
+            </a:pPr>
+            <a:r>
+              <a:rPr lang="en-US" dirty="0">
+                <a:latin typeface="Calibri"/>
+                <a:ea typeface="Calibri"/>
+                <a:cs typeface="Calibri"/>
+                <a:sym typeface="Calibri"/>
+              </a:rPr>
+              <a:t>It was an SQL database for doing analytics (as opposed to transactional processing).</a:t>
+            </a:r>
+            <a:endParaRPr dirty="0">
+              <a:latin typeface="Calibri"/>
+              <a:ea typeface="Calibri"/>
+              <a:cs typeface="Calibri"/>
+              <a:sym typeface="Calibri"/>
+            </a:endParaRPr>
+          </a:p>
+          <a:p>
+            <a:pPr marL="0" lvl="0" indent="0" algn="l" rtl="0">
+              <a:spcBef>
+                <a:spcPts val="0"/>
+              </a:spcBef>
+              <a:spcAft>
+                <a:spcPts val="0"/>
+              </a:spcAft>
+              <a:buNone/>
+            </a:pPr>
+            <a:endParaRPr dirty="0">
+              <a:latin typeface="Calibri"/>
+              <a:ea typeface="Calibri"/>
+              <a:cs typeface="Calibri"/>
+              <a:sym typeface="Calibri"/>
+            </a:endParaRPr>
+          </a:p>
+          <a:p>
+            <a:pPr marL="0" lvl="0" indent="0" algn="l" rtl="0">
+              <a:spcBef>
+                <a:spcPts val="0"/>
+              </a:spcBef>
+              <a:spcAft>
+                <a:spcPts val="0"/>
+              </a:spcAft>
+              <a:buNone/>
+            </a:pPr>
+            <a:r>
+              <a:rPr lang="en-US" dirty="0">
+                <a:latin typeface="Calibri"/>
+                <a:ea typeface="Calibri"/>
+                <a:cs typeface="Calibri"/>
+                <a:sym typeface="Calibri"/>
+              </a:rPr>
+              <a:t>Since then most SQL database vendors have adopted this "</a:t>
+            </a:r>
+            <a:r>
+              <a:rPr lang="en-US" b="1" dirty="0">
+                <a:solidFill>
+                  <a:srgbClr val="0070C0"/>
+                </a:solidFill>
+                <a:latin typeface="Calibri"/>
+                <a:ea typeface="Calibri"/>
+                <a:cs typeface="Calibri"/>
+                <a:sym typeface="Calibri"/>
+              </a:rPr>
+              <a:t>columnar indexing</a:t>
+            </a:r>
+            <a:r>
+              <a:rPr lang="en-US" dirty="0">
+                <a:latin typeface="Calibri"/>
+                <a:ea typeface="Calibri"/>
+                <a:cs typeface="Calibri"/>
+                <a:sym typeface="Calibri"/>
+              </a:rPr>
+              <a:t>". They switched from </a:t>
+            </a:r>
+            <a:r>
+              <a:rPr lang="en-US" b="1" dirty="0">
+                <a:solidFill>
+                  <a:srgbClr val="0070C0"/>
+                </a:solidFill>
+                <a:latin typeface="Calibri"/>
+                <a:ea typeface="Calibri"/>
+                <a:cs typeface="Calibri"/>
+                <a:sym typeface="Calibri"/>
+              </a:rPr>
+              <a:t>row-oriented</a:t>
+            </a:r>
+            <a:r>
+              <a:rPr lang="en-US" dirty="0">
+                <a:latin typeface="Calibri"/>
+                <a:ea typeface="Calibri"/>
+                <a:cs typeface="Calibri"/>
+                <a:sym typeface="Calibri"/>
+              </a:rPr>
+              <a:t> storage and indexing to </a:t>
+            </a:r>
+            <a:r>
+              <a:rPr lang="en-US" b="1" dirty="0">
+                <a:solidFill>
+                  <a:srgbClr val="0070C0"/>
+                </a:solidFill>
+                <a:latin typeface="Calibri"/>
+                <a:ea typeface="Calibri"/>
+                <a:cs typeface="Calibri"/>
+                <a:sym typeface="Calibri"/>
+              </a:rPr>
+              <a:t>compressed column-oriented storage</a:t>
+            </a:r>
+            <a:r>
+              <a:rPr lang="en-US" dirty="0">
+                <a:latin typeface="Calibri"/>
+                <a:ea typeface="Calibri"/>
+                <a:cs typeface="Calibri"/>
+                <a:sym typeface="Calibri"/>
+              </a:rPr>
+              <a:t>. </a:t>
+            </a:r>
+          </a:p>
+          <a:p>
+            <a:pPr marL="0" lvl="0" indent="0" algn="l" rtl="0">
+              <a:spcBef>
+                <a:spcPts val="0"/>
+              </a:spcBef>
+              <a:spcAft>
+                <a:spcPts val="0"/>
+              </a:spcAft>
+              <a:buNone/>
+            </a:pPr>
+            <a:endParaRPr dirty="0">
+              <a:latin typeface="Calibri"/>
+              <a:ea typeface="Calibri"/>
+              <a:cs typeface="Calibri"/>
+              <a:sym typeface="Calibri"/>
+            </a:endParaRPr>
+          </a:p>
+          <a:p>
+            <a:pPr marL="0" lvl="0" indent="0" algn="l" rtl="0">
+              <a:spcBef>
+                <a:spcPts val="0"/>
+              </a:spcBef>
+              <a:spcAft>
+                <a:spcPts val="0"/>
+              </a:spcAft>
+              <a:buNone/>
+            </a:pPr>
+            <a:r>
+              <a:rPr lang="en-US" dirty="0">
+                <a:latin typeface="Calibri"/>
+                <a:ea typeface="Calibri"/>
+                <a:cs typeface="Calibri"/>
+                <a:sym typeface="Calibri"/>
+              </a:rPr>
+              <a:t>This is basically equivalent to the "</a:t>
+            </a:r>
+            <a:r>
+              <a:rPr lang="en-US" b="1" dirty="0">
+                <a:solidFill>
+                  <a:srgbClr val="0070C0"/>
+                </a:solidFill>
+                <a:latin typeface="Calibri"/>
+                <a:ea typeface="Calibri"/>
+                <a:cs typeface="Calibri"/>
+                <a:sym typeface="Calibri"/>
+              </a:rPr>
+              <a:t>Inverted Index</a:t>
+            </a:r>
+            <a:r>
+              <a:rPr lang="en-US" dirty="0">
+                <a:latin typeface="Calibri"/>
+                <a:ea typeface="Calibri"/>
+                <a:cs typeface="Calibri"/>
+                <a:sym typeface="Calibri"/>
+              </a:rPr>
+              <a:t>" idea.</a:t>
+            </a:r>
+            <a:endParaRPr dirty="0">
+              <a:latin typeface="Calibri"/>
+              <a:ea typeface="Calibri"/>
+              <a:cs typeface="Calibri"/>
+              <a:sym typeface="Calibri"/>
+            </a:endParaRPr>
+          </a:p>
+          <a:p>
+            <a:pPr marL="0" lvl="0" indent="0" algn="l" rtl="0">
+              <a:spcBef>
+                <a:spcPts val="0"/>
+              </a:spcBef>
+              <a:spcAft>
+                <a:spcPts val="0"/>
+              </a:spcAft>
+              <a:buNone/>
+            </a:pPr>
+            <a:endParaRPr dirty="0">
+              <a:latin typeface="Calibri"/>
+              <a:ea typeface="Calibri"/>
+              <a:cs typeface="Calibri"/>
+              <a:sym typeface="Calibri"/>
+            </a:endParaRPr>
+          </a:p>
+          <a:p>
+            <a:pPr marL="0" lvl="0" indent="0" algn="l" rtl="0">
+              <a:spcBef>
+                <a:spcPts val="0"/>
+              </a:spcBef>
+              <a:spcAft>
+                <a:spcPts val="0"/>
+              </a:spcAft>
+              <a:buNone/>
+            </a:pPr>
+            <a:r>
+              <a:rPr lang="en-US" dirty="0">
+                <a:latin typeface="Calibri"/>
+                <a:ea typeface="Calibri"/>
+                <a:cs typeface="Calibri"/>
+                <a:sym typeface="Calibri"/>
+              </a:rPr>
+              <a:t>Modern SQL databases can provide performance much faster than EA. You just need to select an implementation with appropriate characteristics.</a:t>
+            </a:r>
+            <a:endParaRPr dirty="0">
+              <a:latin typeface="Calibri"/>
+              <a:ea typeface="Calibri"/>
+              <a:cs typeface="Calibri"/>
+              <a:sym typeface="Calibri"/>
+            </a:endParaRPr>
+          </a:p>
+          <a:p>
+            <a:pPr marL="0" lvl="0" indent="0" algn="l" rtl="0">
+              <a:spcBef>
+                <a:spcPts val="0"/>
+              </a:spcBef>
+              <a:spcAft>
+                <a:spcPts val="0"/>
+              </a:spcAft>
+              <a:buNone/>
+            </a:pPr>
+            <a:endParaRPr dirty="0">
+              <a:latin typeface="Calibri"/>
+              <a:ea typeface="Calibri"/>
+              <a:cs typeface="Calibri"/>
+              <a:sym typeface="Calibri"/>
+            </a:endParaRPr>
+          </a:p>
+          <a:p>
+            <a:pPr marL="0" lvl="0" indent="0" algn="l" rtl="0">
+              <a:spcBef>
+                <a:spcPts val="0"/>
+              </a:spcBef>
+              <a:spcAft>
+                <a:spcPts val="0"/>
+              </a:spcAft>
+              <a:buNone/>
+            </a:pPr>
+            <a:r>
+              <a:rPr lang="en-US" dirty="0">
+                <a:latin typeface="Calibri"/>
+                <a:ea typeface="Calibri"/>
+                <a:cs typeface="Calibri"/>
+                <a:sym typeface="Calibri"/>
+              </a:rPr>
+              <a:t>For example, on AWS (or other clouds) you can select a GPU-based SQL database on a server with terabytes of memory.</a:t>
+            </a:r>
+            <a:endParaRPr dirty="0">
+              <a:latin typeface="Calibri"/>
+              <a:ea typeface="Calibri"/>
+              <a:cs typeface="Calibri"/>
+              <a:sym typeface="Calibri"/>
+            </a:endParaRPr>
+          </a:p>
+          <a:p>
+            <a:pPr marL="0" lvl="0" indent="0" algn="l" rtl="0">
+              <a:spcBef>
+                <a:spcPts val="0"/>
+              </a:spcBef>
+              <a:spcAft>
+                <a:spcPts val="0"/>
+              </a:spcAft>
+              <a:buNone/>
+            </a:pPr>
+            <a:r>
+              <a:rPr lang="en-US" dirty="0">
+                <a:latin typeface="Calibri"/>
+                <a:ea typeface="Calibri"/>
+                <a:cs typeface="Calibri"/>
+                <a:sym typeface="Calibri"/>
+              </a:rPr>
+              <a:t>This database can query the data and give updates with a speed of a live movie (milliseconds) !!</a:t>
+            </a:r>
+            <a:endParaRPr dirty="0">
+              <a:latin typeface="Calibri"/>
+              <a:ea typeface="Calibri"/>
+              <a:cs typeface="Calibri"/>
+              <a:sym typeface="Calibri"/>
+            </a:endParaRPr>
+          </a:p>
+          <a:p>
+            <a:pPr marL="0" lvl="0" indent="0" algn="l" rtl="0">
+              <a:spcBef>
+                <a:spcPts val="0"/>
+              </a:spcBef>
+              <a:spcAft>
+                <a:spcPts val="0"/>
+              </a:spcAft>
+              <a:buNone/>
+            </a:pPr>
+            <a:endParaRPr lang="en-US" dirty="0">
+              <a:latin typeface="Calibri"/>
+              <a:ea typeface="Calibri"/>
+              <a:cs typeface="Calibri"/>
+              <a:sym typeface="Calibri"/>
+            </a:endParaRPr>
+          </a:p>
+          <a:p>
+            <a:pPr marL="0" lvl="0" indent="0" algn="l" rtl="0">
+              <a:spcBef>
+                <a:spcPts val="0"/>
+              </a:spcBef>
+              <a:spcAft>
+                <a:spcPts val="0"/>
+              </a:spcAft>
+              <a:buNone/>
+            </a:pPr>
+            <a:r>
+              <a:rPr lang="en-US" dirty="0">
+                <a:latin typeface="Calibri"/>
+                <a:ea typeface="Calibri"/>
+                <a:cs typeface="Calibri"/>
+                <a:sym typeface="Calibri"/>
+              </a:rPr>
+              <a:t>And we can still use conventional ETL tools and enjoy fast data load speeds.</a:t>
+            </a:r>
+            <a:endParaRPr dirty="0">
+              <a:latin typeface="Calibri"/>
+              <a:ea typeface="Calibri"/>
+              <a:cs typeface="Calibri"/>
+              <a:sym typeface="Calibri"/>
+            </a:endParaRPr>
+          </a:p>
+        </p:txBody>
+      </p:sp>
+      <p:sp>
+        <p:nvSpPr>
+          <p:cNvPr id="120" name="Google Shape;120;p17"/>
+          <p:cNvSpPr txBox="1"/>
+          <p:nvPr/>
+        </p:nvSpPr>
+        <p:spPr>
+          <a:xfrm>
+            <a:off x="85728" y="5228865"/>
+            <a:ext cx="7125000" cy="1543500"/>
+          </a:xfrm>
+          <a:prstGeom prst="rect">
+            <a:avLst/>
+          </a:prstGeom>
+          <a:noFill/>
+          <a:ln>
+            <a:noFill/>
+          </a:ln>
+        </p:spPr>
+        <p:txBody>
+          <a:bodyPr spcFirstLastPara="1" wrap="square" lIns="91425" tIns="91425" rIns="91425" bIns="91425" anchor="t" anchorCtr="0">
+            <a:noAutofit/>
+          </a:bodyPr>
+          <a:lstStyle/>
+          <a:p>
+            <a:pPr marL="0" lvl="0" indent="0" algn="l" rtl="0">
+              <a:spcBef>
+                <a:spcPts val="0"/>
+              </a:spcBef>
+              <a:spcAft>
+                <a:spcPts val="0"/>
+              </a:spcAft>
+              <a:buNone/>
+            </a:pPr>
+            <a:r>
+              <a:rPr lang="en-US" dirty="0">
+                <a:latin typeface="Calibri"/>
+                <a:ea typeface="Calibri"/>
+                <a:cs typeface="Calibri"/>
+                <a:sym typeface="Calibri"/>
+              </a:rPr>
+              <a:t>Inverted indexes are usually implemented as compressed bitmaps - and cached in memory.</a:t>
+            </a:r>
+            <a:endParaRPr dirty="0">
+              <a:latin typeface="Calibri"/>
+              <a:ea typeface="Calibri"/>
+              <a:cs typeface="Calibri"/>
+              <a:sym typeface="Calibri"/>
+            </a:endParaRPr>
+          </a:p>
+          <a:p>
+            <a:pPr marL="0" lvl="0" indent="0" algn="l" rtl="0">
+              <a:spcBef>
+                <a:spcPts val="0"/>
+              </a:spcBef>
+              <a:spcAft>
+                <a:spcPts val="0"/>
+              </a:spcAft>
+              <a:buNone/>
+            </a:pPr>
+            <a:r>
+              <a:rPr lang="en-US" dirty="0">
+                <a:latin typeface="Calibri"/>
+                <a:ea typeface="Calibri"/>
+                <a:cs typeface="Calibri"/>
+                <a:sym typeface="Calibri"/>
+              </a:rPr>
+              <a:t>They may be also implemented as "conventional" trees.</a:t>
+            </a:r>
+            <a:endParaRPr dirty="0">
+              <a:latin typeface="Calibri"/>
+              <a:ea typeface="Calibri"/>
+              <a:cs typeface="Calibri"/>
+              <a:sym typeface="Calibri"/>
+            </a:endParaRPr>
+          </a:p>
+          <a:p>
+            <a:pPr marL="0" lvl="0" indent="0" algn="l" rtl="0">
+              <a:spcBef>
+                <a:spcPts val="0"/>
+              </a:spcBef>
+              <a:spcAft>
+                <a:spcPts val="0"/>
+              </a:spcAft>
+              <a:buNone/>
+            </a:pPr>
+            <a:r>
+              <a:rPr lang="en-US" dirty="0">
+                <a:latin typeface="Calibri"/>
+                <a:ea typeface="Calibri"/>
+                <a:cs typeface="Calibri"/>
+                <a:sym typeface="Calibri"/>
+              </a:rPr>
+              <a:t>Here are more links about Inverted indexes:</a:t>
+            </a:r>
+            <a:endParaRPr dirty="0">
+              <a:latin typeface="Calibri"/>
+              <a:ea typeface="Calibri"/>
+              <a:cs typeface="Calibri"/>
+              <a:sym typeface="Calibri"/>
+            </a:endParaRPr>
+          </a:p>
+          <a:p>
+            <a:pPr marL="0" lvl="0" indent="0" algn="l" rtl="0">
+              <a:spcBef>
+                <a:spcPts val="0"/>
+              </a:spcBef>
+              <a:spcAft>
+                <a:spcPts val="0"/>
+              </a:spcAft>
+              <a:buNone/>
+            </a:pPr>
+            <a:r>
+              <a:rPr lang="en-US" sz="1100" dirty="0">
+                <a:latin typeface="Calibri"/>
+                <a:ea typeface="Calibri"/>
+                <a:cs typeface="Calibri"/>
+                <a:sym typeface="Calibri"/>
+              </a:rPr>
+              <a:t>- </a:t>
+            </a:r>
+            <a:r>
+              <a:rPr lang="en-US" sz="1100" u="sng" dirty="0">
+                <a:solidFill>
+                  <a:schemeClr val="hlink"/>
+                </a:solidFill>
+                <a:latin typeface="Calibri"/>
+                <a:ea typeface="Calibri"/>
+                <a:cs typeface="Calibri"/>
+                <a:sym typeface="Calibri"/>
+                <a:hlinkClick r:id="rId4"/>
+              </a:rPr>
+              <a:t>https://www.quora.com/In-database-design-what-exactly-is-the-difference-between-inverted-index-and-a-normal-index</a:t>
+            </a:r>
+            <a:r>
+              <a:rPr lang="en-US" sz="1100" dirty="0">
+                <a:latin typeface="Calibri"/>
+                <a:ea typeface="Calibri"/>
+                <a:cs typeface="Calibri"/>
+                <a:sym typeface="Calibri"/>
+              </a:rPr>
+              <a:t> </a:t>
+            </a:r>
+            <a:endParaRPr sz="1100" dirty="0">
+              <a:latin typeface="Calibri"/>
+              <a:ea typeface="Calibri"/>
+              <a:cs typeface="Calibri"/>
+              <a:sym typeface="Calibri"/>
+            </a:endParaRPr>
+          </a:p>
+          <a:p>
+            <a:pPr marL="0" lvl="0" indent="0" algn="l" rtl="0">
+              <a:spcBef>
+                <a:spcPts val="0"/>
+              </a:spcBef>
+              <a:spcAft>
+                <a:spcPts val="0"/>
+              </a:spcAft>
+              <a:buNone/>
+            </a:pPr>
+            <a:r>
+              <a:rPr lang="en-US" sz="1100" dirty="0">
+                <a:latin typeface="Calibri"/>
+                <a:ea typeface="Calibri"/>
+                <a:cs typeface="Calibri"/>
+                <a:sym typeface="Calibri"/>
+              </a:rPr>
+              <a:t>- </a:t>
+            </a:r>
+            <a:r>
+              <a:rPr lang="en-US" sz="1100" u="sng" dirty="0">
+                <a:solidFill>
+                  <a:schemeClr val="hlink"/>
+                </a:solidFill>
+                <a:latin typeface="Calibri"/>
+                <a:ea typeface="Calibri"/>
+                <a:cs typeface="Calibri"/>
+                <a:sym typeface="Calibri"/>
+                <a:hlinkClick r:id="rId5"/>
+              </a:rPr>
+              <a:t>https://stackoverflow.com/questions/47537318/b-tree-index-vs-inverted-index</a:t>
+            </a:r>
+            <a:r>
+              <a:rPr lang="en-US" sz="1100" dirty="0">
+                <a:latin typeface="Calibri"/>
+                <a:ea typeface="Calibri"/>
+                <a:cs typeface="Calibri"/>
+                <a:sym typeface="Calibri"/>
+              </a:rPr>
+              <a:t> </a:t>
+            </a:r>
+            <a:endParaRPr sz="1100" dirty="0">
+              <a:latin typeface="Calibri"/>
+              <a:ea typeface="Calibri"/>
+              <a:cs typeface="Calibri"/>
+              <a:sym typeface="Calibri"/>
+            </a:endParaRPr>
+          </a:p>
+          <a:p>
+            <a:pPr marL="0" lvl="0" indent="0" algn="l" rtl="0">
+              <a:spcBef>
+                <a:spcPts val="0"/>
+              </a:spcBef>
+              <a:spcAft>
+                <a:spcPts val="0"/>
+              </a:spcAft>
+              <a:buNone/>
+            </a:pPr>
+            <a:r>
+              <a:rPr lang="en-US" sz="1100" dirty="0">
+                <a:latin typeface="Calibri"/>
+                <a:ea typeface="Calibri"/>
+                <a:cs typeface="Calibri"/>
+                <a:sym typeface="Calibri"/>
+              </a:rPr>
+              <a:t>- </a:t>
+            </a:r>
+            <a:r>
+              <a:rPr lang="en-US" sz="1100" u="sng" dirty="0">
+                <a:solidFill>
+                  <a:schemeClr val="hlink"/>
+                </a:solidFill>
+                <a:latin typeface="Calibri"/>
+                <a:ea typeface="Calibri"/>
+                <a:cs typeface="Calibri"/>
+                <a:sym typeface="Calibri"/>
+                <a:hlinkClick r:id="rId6"/>
+              </a:rPr>
+              <a:t>https://en.wikipedia.org/wiki/Inverted_index</a:t>
+            </a:r>
+            <a:r>
+              <a:rPr lang="en-US" sz="1100" dirty="0">
+                <a:latin typeface="Calibri"/>
+                <a:ea typeface="Calibri"/>
+                <a:cs typeface="Calibri"/>
+                <a:sym typeface="Calibri"/>
+              </a:rPr>
+              <a:t> </a:t>
+            </a:r>
+            <a:endParaRPr dirty="0">
+              <a:latin typeface="Calibri"/>
+              <a:ea typeface="Calibri"/>
+              <a:cs typeface="Calibri"/>
+              <a:sym typeface="Calibri"/>
+            </a:endParaRPr>
+          </a:p>
+        </p:txBody>
+      </p:sp>
+    </p:spTree>
   </p:cSld>
   <p:clrMapOvr>
     <a:masterClrMapping/>

</xml_diff>